<commit_message>
Added 1D dms and pes plots.
</commit_message>
<xml_diff>
--- a/HPO_figures.pptx
+++ b/HPO_figures.pptx
@@ -6,6 +6,7 @@
   </p:sldMasterIdLst>
   <p:sldIdLst>
     <p:sldId id="256" r:id="rId2"/>
+    <p:sldId id="257" r:id="rId3"/>
   </p:sldIdLst>
   <p:sldSz cx="12192000" cy="6858000"/>
   <p:notesSz cx="6858000" cy="9144000"/>
@@ -104,7 +105,272 @@
       </a:defRPr>
     </a:lvl9pPr>
   </p:defaultTextStyle>
+  <p:extLst>
+    <p:ext uri="{EFAFB233-063F-42B5-8137-9DF3F51BA10A}">
+      <p15:sldGuideLst xmlns:p15="http://schemas.microsoft.com/office/powerpoint/2012/main"/>
+    </p:ext>
+  </p:extLst>
 </p:presentation>
+</file>
+
+<file path=ppt/revisionInfo.xml><?xml version="1.0" encoding="utf-8"?>
+<p1510:revInfo xmlns:a="http://schemas.openxmlformats.org/drawingml/2006/main" xmlns:r="http://schemas.openxmlformats.org/officeDocument/2006/relationships" xmlns:p1510="http://schemas.microsoft.com/office/powerpoint/2015/10/main">
+  <p1510:revLst>
+    <p1510:client id="{80AB0109-F0B2-4F8E-80E6-FA50717ECDA8}" v="27" dt="2026-08-17T17:29:19.905"/>
+  </p1510:revLst>
+</p1510:revInfo>
+</file>
+
+<file path=ppt/changesInfos/changesInfo1.xml><?xml version="1.0" encoding="utf-8"?>
+<pc:chgInfo xmlns:a="http://schemas.openxmlformats.org/drawingml/2006/main" xmlns:r="http://schemas.openxmlformats.org/officeDocument/2006/relationships" xmlns:ac="http://schemas.microsoft.com/office/drawing/2013/main/command" xmlns:pc="http://schemas.microsoft.com/office/powerpoint/2013/main/command">
+  <pc:docChgLst>
+    <pc:chgData name="Ryan Mok" userId="2b5ff9b4bc27d924" providerId="LiveId" clId="{98BDB49B-93C9-4AB7-A5FC-395AE49E91C6}"/>
+    <pc:docChg chg="undo custSel addSld modSld">
+      <pc:chgData name="Ryan Mok" userId="2b5ff9b4bc27d924" providerId="LiveId" clId="{98BDB49B-93C9-4AB7-A5FC-395AE49E91C6}" dt="2026-08-17T17:29:34.288" v="223" actId="1037"/>
+      <pc:docMkLst>
+        <pc:docMk/>
+      </pc:docMkLst>
+      <pc:sldChg chg="addSp modSp mod">
+        <pc:chgData name="Ryan Mok" userId="2b5ff9b4bc27d924" providerId="LiveId" clId="{98BDB49B-93C9-4AB7-A5FC-395AE49E91C6}" dt="2026-08-16T00:27:42.662" v="25" actId="255"/>
+        <pc:sldMkLst>
+          <pc:docMk/>
+          <pc:sldMk cId="2699379521" sldId="256"/>
+        </pc:sldMkLst>
+        <pc:spChg chg="mod">
+          <ac:chgData name="Ryan Mok" userId="2b5ff9b4bc27d924" providerId="LiveId" clId="{98BDB49B-93C9-4AB7-A5FC-395AE49E91C6}" dt="2026-08-16T00:27:42.662" v="25" actId="255"/>
+          <ac:spMkLst>
+            <pc:docMk/>
+            <pc:sldMk cId="2699379521" sldId="256"/>
+            <ac:spMk id="10" creationId="{A7F54FCE-EB27-CE40-B532-3B142060A817}"/>
+          </ac:spMkLst>
+        </pc:spChg>
+        <pc:spChg chg="mod">
+          <ac:chgData name="Ryan Mok" userId="2b5ff9b4bc27d924" providerId="LiveId" clId="{98BDB49B-93C9-4AB7-A5FC-395AE49E91C6}" dt="2026-08-16T00:25:36.079" v="18" actId="255"/>
+          <ac:spMkLst>
+            <pc:docMk/>
+            <pc:sldMk cId="2699379521" sldId="256"/>
+            <ac:spMk id="22" creationId="{3AD5A7CD-FFA7-1C22-ECDD-3CC12CC49CFF}"/>
+          </ac:spMkLst>
+        </pc:spChg>
+        <pc:spChg chg="mod">
+          <ac:chgData name="Ryan Mok" userId="2b5ff9b4bc27d924" providerId="LiveId" clId="{98BDB49B-93C9-4AB7-A5FC-395AE49E91C6}" dt="2026-08-16T00:26:22.257" v="24" actId="255"/>
+          <ac:spMkLst>
+            <pc:docMk/>
+            <pc:sldMk cId="2699379521" sldId="256"/>
+            <ac:spMk id="24" creationId="{153C7F94-AE14-C825-0F86-BA1FC1E9CD19}"/>
+          </ac:spMkLst>
+        </pc:spChg>
+        <pc:spChg chg="mod">
+          <ac:chgData name="Ryan Mok" userId="2b5ff9b4bc27d924" providerId="LiveId" clId="{98BDB49B-93C9-4AB7-A5FC-395AE49E91C6}" dt="2026-08-16T00:25:39.334" v="19" actId="1076"/>
+          <ac:spMkLst>
+            <pc:docMk/>
+            <pc:sldMk cId="2699379521" sldId="256"/>
+            <ac:spMk id="44" creationId="{B16D9865-B805-47CF-D47A-58BCCB3967A0}"/>
+          </ac:spMkLst>
+        </pc:spChg>
+        <pc:spChg chg="mod">
+          <ac:chgData name="Ryan Mok" userId="2b5ff9b4bc27d924" providerId="LiveId" clId="{98BDB49B-93C9-4AB7-A5FC-395AE49E91C6}" dt="2026-08-16T00:25:36.079" v="18" actId="255"/>
+          <ac:spMkLst>
+            <pc:docMk/>
+            <pc:sldMk cId="2699379521" sldId="256"/>
+            <ac:spMk id="46" creationId="{FD510F8C-974C-6C01-403B-FA9AFEDA2154}"/>
+          </ac:spMkLst>
+        </pc:spChg>
+        <pc:spChg chg="mod">
+          <ac:chgData name="Ryan Mok" userId="2b5ff9b4bc27d924" providerId="LiveId" clId="{98BDB49B-93C9-4AB7-A5FC-395AE49E91C6}" dt="2026-08-16T00:25:59.003" v="22" actId="692"/>
+          <ac:spMkLst>
+            <pc:docMk/>
+            <pc:sldMk cId="2699379521" sldId="256"/>
+            <ac:spMk id="47" creationId="{5A0802CB-0934-7C5F-3F85-9C5B47DC1B39}"/>
+          </ac:spMkLst>
+        </pc:spChg>
+        <pc:spChg chg="mod">
+          <ac:chgData name="Ryan Mok" userId="2b5ff9b4bc27d924" providerId="LiveId" clId="{98BDB49B-93C9-4AB7-A5FC-395AE49E91C6}" dt="2026-08-16T00:25:36.079" v="18" actId="255"/>
+          <ac:spMkLst>
+            <pc:docMk/>
+            <pc:sldMk cId="2699379521" sldId="256"/>
+            <ac:spMk id="49" creationId="{2D02E829-C8AA-E5E7-8819-945B2B4170E4}"/>
+          </ac:spMkLst>
+        </pc:spChg>
+        <pc:grpChg chg="add mod">
+          <ac:chgData name="Ryan Mok" userId="2b5ff9b4bc27d924" providerId="LiveId" clId="{98BDB49B-93C9-4AB7-A5FC-395AE49E91C6}" dt="2026-08-16T00:25:36.079" v="18" actId="255"/>
+          <ac:grpSpMkLst>
+            <pc:docMk/>
+            <pc:sldMk cId="2699379521" sldId="256"/>
+            <ac:grpSpMk id="2" creationId="{80C08A19-6C3D-459F-2C9C-FAF7B60D2317}"/>
+          </ac:grpSpMkLst>
+        </pc:grpChg>
+        <pc:cxnChg chg="mod">
+          <ac:chgData name="Ryan Mok" userId="2b5ff9b4bc27d924" providerId="LiveId" clId="{98BDB49B-93C9-4AB7-A5FC-395AE49E91C6}" dt="2026-08-16T00:25:36.079" v="18" actId="255"/>
+          <ac:cxnSpMkLst>
+            <pc:docMk/>
+            <pc:sldMk cId="2699379521" sldId="256"/>
+            <ac:cxnSpMk id="11" creationId="{737CFC80-10DC-AA9D-1519-BB19326C3974}"/>
+          </ac:cxnSpMkLst>
+        </pc:cxnChg>
+        <pc:cxnChg chg="mod">
+          <ac:chgData name="Ryan Mok" userId="2b5ff9b4bc27d924" providerId="LiveId" clId="{98BDB49B-93C9-4AB7-A5FC-395AE49E91C6}" dt="2026-08-16T00:26:05.803" v="23" actId="692"/>
+          <ac:cxnSpMkLst>
+            <pc:docMk/>
+            <pc:sldMk cId="2699379521" sldId="256"/>
+            <ac:cxnSpMk id="23" creationId="{18C94983-595E-4B47-3357-348526FA0FB8}"/>
+          </ac:cxnSpMkLst>
+        </pc:cxnChg>
+      </pc:sldChg>
+      <pc:sldChg chg="addSp delSp modSp add mod">
+        <pc:chgData name="Ryan Mok" userId="2b5ff9b4bc27d924" providerId="LiveId" clId="{98BDB49B-93C9-4AB7-A5FC-395AE49E91C6}" dt="2026-08-17T17:29:34.288" v="223" actId="1037"/>
+        <pc:sldMkLst>
+          <pc:docMk/>
+          <pc:sldMk cId="4071236100" sldId="257"/>
+        </pc:sldMkLst>
+        <pc:spChg chg="add mod">
+          <ac:chgData name="Ryan Mok" userId="2b5ff9b4bc27d924" providerId="LiveId" clId="{98BDB49B-93C9-4AB7-A5FC-395AE49E91C6}" dt="2026-08-17T16:45:58.704" v="122" actId="404"/>
+          <ac:spMkLst>
+            <pc:docMk/>
+            <pc:sldMk cId="4071236100" sldId="257"/>
+            <ac:spMk id="9" creationId="{B0B6BFB7-7EFB-DDC3-6926-0EB97780D9CC}"/>
+          </ac:spMkLst>
+        </pc:spChg>
+        <pc:spChg chg="mod topLvl">
+          <ac:chgData name="Ryan Mok" userId="2b5ff9b4bc27d924" providerId="LiveId" clId="{98BDB49B-93C9-4AB7-A5FC-395AE49E91C6}" dt="2026-08-17T16:43:41.882" v="72" actId="1037"/>
+          <ac:spMkLst>
+            <pc:docMk/>
+            <pc:sldMk cId="4071236100" sldId="257"/>
+            <ac:spMk id="10" creationId="{38EF4465-53E9-89D7-ECDB-5EF19EE4809D}"/>
+          </ac:spMkLst>
+        </pc:spChg>
+        <pc:spChg chg="add mod">
+          <ac:chgData name="Ryan Mok" userId="2b5ff9b4bc27d924" providerId="LiveId" clId="{98BDB49B-93C9-4AB7-A5FC-395AE49E91C6}" dt="2026-08-17T16:46:07.933" v="126" actId="20577"/>
+          <ac:spMkLst>
+            <pc:docMk/>
+            <pc:sldMk cId="4071236100" sldId="257"/>
+            <ac:spMk id="13" creationId="{FD075C99-06C4-26D6-83AD-AD6C788886EF}"/>
+          </ac:spMkLst>
+        </pc:spChg>
+        <pc:spChg chg="add mod">
+          <ac:chgData name="Ryan Mok" userId="2b5ff9b4bc27d924" providerId="LiveId" clId="{98BDB49B-93C9-4AB7-A5FC-395AE49E91C6}" dt="2026-08-17T16:46:22.963" v="140" actId="1076"/>
+          <ac:spMkLst>
+            <pc:docMk/>
+            <pc:sldMk cId="4071236100" sldId="257"/>
+            <ac:spMk id="15" creationId="{D29B6249-D196-AC9D-C6B8-018AAD065877}"/>
+          </ac:spMkLst>
+        </pc:spChg>
+        <pc:spChg chg="mod topLvl">
+          <ac:chgData name="Ryan Mok" userId="2b5ff9b4bc27d924" providerId="LiveId" clId="{98BDB49B-93C9-4AB7-A5FC-395AE49E91C6}" dt="2026-08-17T16:43:55.938" v="73" actId="1076"/>
+          <ac:spMkLst>
+            <pc:docMk/>
+            <pc:sldMk cId="4071236100" sldId="257"/>
+            <ac:spMk id="22" creationId="{15F66337-BA7C-C813-B682-C1B81815E3D1}"/>
+          </ac:spMkLst>
+        </pc:spChg>
+        <pc:spChg chg="mod topLvl">
+          <ac:chgData name="Ryan Mok" userId="2b5ff9b4bc27d924" providerId="LiveId" clId="{98BDB49B-93C9-4AB7-A5FC-395AE49E91C6}" dt="2026-08-17T16:43:41.882" v="72" actId="1037"/>
+          <ac:spMkLst>
+            <pc:docMk/>
+            <pc:sldMk cId="4071236100" sldId="257"/>
+            <ac:spMk id="24" creationId="{280447AB-28FE-B511-8F76-F72F2704CC20}"/>
+          </ac:spMkLst>
+        </pc:spChg>
+        <pc:spChg chg="add mod">
+          <ac:chgData name="Ryan Mok" userId="2b5ff9b4bc27d924" providerId="LiveId" clId="{98BDB49B-93C9-4AB7-A5FC-395AE49E91C6}" dt="2026-08-17T17:29:34.288" v="223" actId="1037"/>
+          <ac:spMkLst>
+            <pc:docMk/>
+            <pc:sldMk cId="4071236100" sldId="257"/>
+            <ac:spMk id="25" creationId="{DCAE7460-EF02-940E-C124-B9FE596D4C3B}"/>
+          </ac:spMkLst>
+        </pc:spChg>
+        <pc:spChg chg="add mod">
+          <ac:chgData name="Ryan Mok" userId="2b5ff9b4bc27d924" providerId="LiveId" clId="{98BDB49B-93C9-4AB7-A5FC-395AE49E91C6}" dt="2026-08-17T17:29:34.288" v="223" actId="1037"/>
+          <ac:spMkLst>
+            <pc:docMk/>
+            <pc:sldMk cId="4071236100" sldId="257"/>
+            <ac:spMk id="27" creationId="{F65D02AF-ECCF-618C-C7C3-834ACFAC9772}"/>
+          </ac:spMkLst>
+        </pc:spChg>
+        <pc:spChg chg="del mod topLvl">
+          <ac:chgData name="Ryan Mok" userId="2b5ff9b4bc27d924" providerId="LiveId" clId="{98BDB49B-93C9-4AB7-A5FC-395AE49E91C6}" dt="2026-08-17T16:42:42.031" v="30" actId="478"/>
+          <ac:spMkLst>
+            <pc:docMk/>
+            <pc:sldMk cId="4071236100" sldId="257"/>
+            <ac:spMk id="44" creationId="{48668747-0EF8-6CDB-4521-9DE0F6D2B67E}"/>
+          </ac:spMkLst>
+        </pc:spChg>
+        <pc:spChg chg="del mod topLvl">
+          <ac:chgData name="Ryan Mok" userId="2b5ff9b4bc27d924" providerId="LiveId" clId="{98BDB49B-93C9-4AB7-A5FC-395AE49E91C6}" dt="2026-08-17T16:42:38.952" v="28" actId="478"/>
+          <ac:spMkLst>
+            <pc:docMk/>
+            <pc:sldMk cId="4071236100" sldId="257"/>
+            <ac:spMk id="46" creationId="{60EB6855-D5BF-1178-281A-C5DD44242AE4}"/>
+          </ac:spMkLst>
+        </pc:spChg>
+        <pc:spChg chg="mod topLvl">
+          <ac:chgData name="Ryan Mok" userId="2b5ff9b4bc27d924" providerId="LiveId" clId="{98BDB49B-93C9-4AB7-A5FC-395AE49E91C6}" dt="2026-08-17T16:44:47.990" v="110" actId="1035"/>
+          <ac:spMkLst>
+            <pc:docMk/>
+            <pc:sldMk cId="4071236100" sldId="257"/>
+            <ac:spMk id="47" creationId="{E00A34CF-8AA1-2586-DF2E-3398498B3F66}"/>
+          </ac:spMkLst>
+        </pc:spChg>
+        <pc:spChg chg="del mod topLvl">
+          <ac:chgData name="Ryan Mok" userId="2b5ff9b4bc27d924" providerId="LiveId" clId="{98BDB49B-93C9-4AB7-A5FC-395AE49E91C6}" dt="2026-08-17T16:42:40.280" v="29" actId="478"/>
+          <ac:spMkLst>
+            <pc:docMk/>
+            <pc:sldMk cId="4071236100" sldId="257"/>
+            <ac:spMk id="49" creationId="{CC6421EA-F318-63B8-8604-FBD39F64576B}"/>
+          </ac:spMkLst>
+        </pc:spChg>
+        <pc:grpChg chg="del">
+          <ac:chgData name="Ryan Mok" userId="2b5ff9b4bc27d924" providerId="LiveId" clId="{98BDB49B-93C9-4AB7-A5FC-395AE49E91C6}" dt="2026-08-17T16:42:36.987" v="27" actId="165"/>
+          <ac:grpSpMkLst>
+            <pc:docMk/>
+            <pc:sldMk cId="4071236100" sldId="257"/>
+            <ac:grpSpMk id="2" creationId="{A9649E30-066A-D4F8-C8F4-A0E0FE3C1924}"/>
+          </ac:grpSpMkLst>
+        </pc:grpChg>
+        <pc:grpChg chg="add mod">
+          <ac:chgData name="Ryan Mok" userId="2b5ff9b4bc27d924" providerId="LiveId" clId="{98BDB49B-93C9-4AB7-A5FC-395AE49E91C6}" dt="2026-08-17T17:29:34.288" v="223" actId="1037"/>
+          <ac:grpSpMkLst>
+            <pc:docMk/>
+            <pc:sldMk cId="4071236100" sldId="257"/>
+            <ac:grpSpMk id="20" creationId="{612D1359-D49E-F522-3580-95ACCFAD79ED}"/>
+          </ac:grpSpMkLst>
+        </pc:grpChg>
+        <pc:cxnChg chg="mod topLvl">
+          <ac:chgData name="Ryan Mok" userId="2b5ff9b4bc27d924" providerId="LiveId" clId="{98BDB49B-93C9-4AB7-A5FC-395AE49E91C6}" dt="2026-08-17T16:43:59.037" v="74" actId="14100"/>
+          <ac:cxnSpMkLst>
+            <pc:docMk/>
+            <pc:sldMk cId="4071236100" sldId="257"/>
+            <ac:cxnSpMk id="11" creationId="{D53ADA0E-5BF2-20F8-24B9-306BCEC2A521}"/>
+          </ac:cxnSpMkLst>
+        </pc:cxnChg>
+        <pc:cxnChg chg="add mod">
+          <ac:chgData name="Ryan Mok" userId="2b5ff9b4bc27d924" providerId="LiveId" clId="{98BDB49B-93C9-4AB7-A5FC-395AE49E91C6}" dt="2026-08-17T17:28:56.415" v="200" actId="164"/>
+          <ac:cxnSpMkLst>
+            <pc:docMk/>
+            <pc:sldMk cId="4071236100" sldId="257"/>
+            <ac:cxnSpMk id="16" creationId="{96AEE7BF-AE50-F70D-1016-7AC735D1419B}"/>
+          </ac:cxnSpMkLst>
+        </pc:cxnChg>
+        <pc:cxnChg chg="add mod">
+          <ac:chgData name="Ryan Mok" userId="2b5ff9b4bc27d924" providerId="LiveId" clId="{98BDB49B-93C9-4AB7-A5FC-395AE49E91C6}" dt="2026-08-17T17:28:56.415" v="200" actId="164"/>
+          <ac:cxnSpMkLst>
+            <pc:docMk/>
+            <pc:sldMk cId="4071236100" sldId="257"/>
+            <ac:cxnSpMk id="18" creationId="{E4F6C35F-EC06-C35D-DB8C-CC0A42733084}"/>
+          </ac:cxnSpMkLst>
+        </pc:cxnChg>
+        <pc:cxnChg chg="mod topLvl">
+          <ac:chgData name="Ryan Mok" userId="2b5ff9b4bc27d924" providerId="LiveId" clId="{98BDB49B-93C9-4AB7-A5FC-395AE49E91C6}" dt="2026-08-17T16:43:41.882" v="72" actId="1037"/>
+          <ac:cxnSpMkLst>
+            <pc:docMk/>
+            <pc:sldMk cId="4071236100" sldId="257"/>
+            <ac:cxnSpMk id="23" creationId="{0F295CC0-DBF8-EFC2-9AF0-828D01A890F9}"/>
+          </ac:cxnSpMkLst>
+        </pc:cxnChg>
+      </pc:sldChg>
+    </pc:docChg>
+  </pc:docChgLst>
+</pc:chgInfo>
 </file>
 
 <file path=ppt/slideLayouts/slideLayout1.xml><?xml version="1.0" encoding="utf-8"?>
@@ -256,7 +522,7 @@
           <a:p>
             <a:fld id="{B9F7AD3A-2E00-40AC-B4EF-D2178F39DCFF}" type="datetimeFigureOut">
               <a:rPr lang="en-GB" smtClean="0"/>
-              <a:t>30/07/2026</a:t>
+              <a:t>17/08/2026</a:t>
             </a:fld>
             <a:endParaRPr lang="en-GB"/>
           </a:p>
@@ -456,7 +722,7 @@
           <a:p>
             <a:fld id="{B9F7AD3A-2E00-40AC-B4EF-D2178F39DCFF}" type="datetimeFigureOut">
               <a:rPr lang="en-GB" smtClean="0"/>
-              <a:t>30/07/2026</a:t>
+              <a:t>17/08/2026</a:t>
             </a:fld>
             <a:endParaRPr lang="en-GB"/>
           </a:p>
@@ -666,7 +932,7 @@
           <a:p>
             <a:fld id="{B9F7AD3A-2E00-40AC-B4EF-D2178F39DCFF}" type="datetimeFigureOut">
               <a:rPr lang="en-GB" smtClean="0"/>
-              <a:t>30/07/2026</a:t>
+              <a:t>17/08/2026</a:t>
             </a:fld>
             <a:endParaRPr lang="en-GB"/>
           </a:p>
@@ -866,7 +1132,7 @@
           <a:p>
             <a:fld id="{B9F7AD3A-2E00-40AC-B4EF-D2178F39DCFF}" type="datetimeFigureOut">
               <a:rPr lang="en-GB" smtClean="0"/>
-              <a:t>30/07/2026</a:t>
+              <a:t>17/08/2026</a:t>
             </a:fld>
             <a:endParaRPr lang="en-GB"/>
           </a:p>
@@ -1142,7 +1408,7 @@
           <a:p>
             <a:fld id="{B9F7AD3A-2E00-40AC-B4EF-D2178F39DCFF}" type="datetimeFigureOut">
               <a:rPr lang="en-GB" smtClean="0"/>
-              <a:t>30/07/2026</a:t>
+              <a:t>17/08/2026</a:t>
             </a:fld>
             <a:endParaRPr lang="en-GB"/>
           </a:p>
@@ -1410,7 +1676,7 @@
           <a:p>
             <a:fld id="{B9F7AD3A-2E00-40AC-B4EF-D2178F39DCFF}" type="datetimeFigureOut">
               <a:rPr lang="en-GB" smtClean="0"/>
-              <a:t>30/07/2026</a:t>
+              <a:t>17/08/2026</a:t>
             </a:fld>
             <a:endParaRPr lang="en-GB"/>
           </a:p>
@@ -1825,7 +2091,7 @@
           <a:p>
             <a:fld id="{B9F7AD3A-2E00-40AC-B4EF-D2178F39DCFF}" type="datetimeFigureOut">
               <a:rPr lang="en-GB" smtClean="0"/>
-              <a:t>30/07/2026</a:t>
+              <a:t>17/08/2026</a:t>
             </a:fld>
             <a:endParaRPr lang="en-GB"/>
           </a:p>
@@ -1967,7 +2233,7 @@
           <a:p>
             <a:fld id="{B9F7AD3A-2E00-40AC-B4EF-D2178F39DCFF}" type="datetimeFigureOut">
               <a:rPr lang="en-GB" smtClean="0"/>
-              <a:t>30/07/2026</a:t>
+              <a:t>17/08/2026</a:t>
             </a:fld>
             <a:endParaRPr lang="en-GB"/>
           </a:p>
@@ -2080,7 +2346,7 @@
           <a:p>
             <a:fld id="{B9F7AD3A-2E00-40AC-B4EF-D2178F39DCFF}" type="datetimeFigureOut">
               <a:rPr lang="en-GB" smtClean="0"/>
-              <a:t>30/07/2026</a:t>
+              <a:t>17/08/2026</a:t>
             </a:fld>
             <a:endParaRPr lang="en-GB"/>
           </a:p>
@@ -2393,7 +2659,7 @@
           <a:p>
             <a:fld id="{B9F7AD3A-2E00-40AC-B4EF-D2178F39DCFF}" type="datetimeFigureOut">
               <a:rPr lang="en-GB" smtClean="0"/>
-              <a:t>30/07/2026</a:t>
+              <a:t>17/08/2026</a:t>
             </a:fld>
             <a:endParaRPr lang="en-GB"/>
           </a:p>
@@ -2682,7 +2948,7 @@
           <a:p>
             <a:fld id="{B9F7AD3A-2E00-40AC-B4EF-D2178F39DCFF}" type="datetimeFigureOut">
               <a:rPr lang="en-GB" smtClean="0"/>
-              <a:t>30/07/2026</a:t>
+              <a:t>17/08/2026</a:t>
             </a:fld>
             <a:endParaRPr lang="en-GB"/>
           </a:p>
@@ -2925,7 +3191,7 @@
           <a:p>
             <a:fld id="{B9F7AD3A-2E00-40AC-B4EF-D2178F39DCFF}" type="datetimeFigureOut">
               <a:rPr lang="en-GB" smtClean="0"/>
-              <a:t>30/07/2026</a:t>
+              <a:t>17/08/2026</a:t>
             </a:fld>
             <a:endParaRPr lang="en-GB"/>
           </a:p>
@@ -3342,12 +3608,713 @@
           <a:chExt cx="0" cy="0"/>
         </a:xfrm>
       </p:grpSpPr>
+      <p:grpSp>
+        <p:nvGrpSpPr>
+          <p:cNvPr id="2" name="Group 1">
+            <a:extLst>
+              <a:ext uri="{FF2B5EF4-FFF2-40B4-BE49-F238E27FC236}">
+                <a16:creationId xmlns:a16="http://schemas.microsoft.com/office/drawing/2014/main" id="{80C08A19-6C3D-459F-2C9C-FAF7B60D2317}"/>
+              </a:ext>
+            </a:extLst>
+          </p:cNvPr>
+          <p:cNvGrpSpPr/>
+          <p:nvPr/>
+        </p:nvGrpSpPr>
+        <p:grpSpPr>
+          <a:xfrm>
+            <a:off x="2529884" y="1485419"/>
+            <a:ext cx="7275240" cy="4403317"/>
+            <a:chOff x="2529884" y="1485419"/>
+            <a:chExt cx="4296945" cy="2600713"/>
+          </a:xfrm>
+        </p:grpSpPr>
+        <p:sp>
+          <p:nvSpPr>
+            <p:cNvPr id="47" name="Arc 46">
+              <a:extLst>
+                <a:ext uri="{FF2B5EF4-FFF2-40B4-BE49-F238E27FC236}">
+                  <a16:creationId xmlns:a16="http://schemas.microsoft.com/office/drawing/2014/main" id="{5A0802CB-0934-7C5F-3F85-9C5B47DC1B39}"/>
+                </a:ext>
+              </a:extLst>
+            </p:cNvPr>
+            <p:cNvSpPr/>
+            <p:nvPr/>
+          </p:nvSpPr>
+          <p:spPr>
+            <a:xfrm rot="8449048">
+              <a:off x="3917299" y="1485419"/>
+              <a:ext cx="1451378" cy="1431365"/>
+            </a:xfrm>
+            <a:prstGeom prst="arc">
+              <a:avLst>
+                <a:gd name="adj1" fmla="val 15496379"/>
+                <a:gd name="adj2" fmla="val 21546438"/>
+              </a:avLst>
+            </a:prstGeom>
+            <a:ln w="38100">
+              <a:solidFill>
+                <a:srgbClr val="FF0000"/>
+              </a:solidFill>
+            </a:ln>
+          </p:spPr>
+          <p:style>
+            <a:lnRef idx="2">
+              <a:schemeClr val="accent1"/>
+            </a:lnRef>
+            <a:fillRef idx="0">
+              <a:schemeClr val="accent1"/>
+            </a:fillRef>
+            <a:effectRef idx="1">
+              <a:schemeClr val="accent1"/>
+            </a:effectRef>
+            <a:fontRef idx="minor">
+              <a:schemeClr val="tx1"/>
+            </a:fontRef>
+          </p:style>
+          <p:txBody>
+            <a:bodyPr rtlCol="0" anchor="ctr"/>
+            <a:lstStyle/>
+            <a:p>
+              <a:pPr algn="ctr"/>
+              <a:endParaRPr lang="en-GB" dirty="0"/>
+            </a:p>
+          </p:txBody>
+        </p:sp>
+        <p:cxnSp>
+          <p:nvCxnSpPr>
+            <p:cNvPr id="11" name="Straight Connector 10">
+              <a:extLst>
+                <a:ext uri="{FF2B5EF4-FFF2-40B4-BE49-F238E27FC236}">
+                  <a16:creationId xmlns:a16="http://schemas.microsoft.com/office/drawing/2014/main" id="{737CFC80-10DC-AA9D-1519-BB19326C3974}"/>
+                </a:ext>
+              </a:extLst>
+            </p:cNvPr>
+            <p:cNvCxnSpPr>
+              <a:cxnSpLocks/>
+            </p:cNvCxnSpPr>
+            <p:nvPr/>
+          </p:nvCxnSpPr>
+          <p:spPr>
+            <a:xfrm flipV="1">
+              <a:off x="2966957" y="2201101"/>
+              <a:ext cx="1667245" cy="1419922"/>
+            </a:xfrm>
+            <a:prstGeom prst="line">
+              <a:avLst/>
+            </a:prstGeom>
+            <a:ln w="38100"/>
+          </p:spPr>
+          <p:style>
+            <a:lnRef idx="2">
+              <a:schemeClr val="dk1"/>
+            </a:lnRef>
+            <a:fillRef idx="0">
+              <a:schemeClr val="dk1"/>
+            </a:fillRef>
+            <a:effectRef idx="1">
+              <a:schemeClr val="dk1"/>
+            </a:effectRef>
+            <a:fontRef idx="minor">
+              <a:schemeClr val="tx1"/>
+            </a:fontRef>
+          </p:style>
+        </p:cxnSp>
+        <p:sp>
+          <p:nvSpPr>
+            <p:cNvPr id="22" name="Oval 21">
+              <a:extLst>
+                <a:ext uri="{FF2B5EF4-FFF2-40B4-BE49-F238E27FC236}">
+                  <a16:creationId xmlns:a16="http://schemas.microsoft.com/office/drawing/2014/main" id="{3AD5A7CD-FFA7-1C22-ECDD-3CC12CC49CFF}"/>
+                </a:ext>
+              </a:extLst>
+            </p:cNvPr>
+            <p:cNvSpPr/>
+            <p:nvPr/>
+          </p:nvSpPr>
+          <p:spPr>
+            <a:xfrm>
+              <a:off x="2529884" y="3146770"/>
+              <a:ext cx="874146" cy="930217"/>
+            </a:xfrm>
+            <a:prstGeom prst="ellipse">
+              <a:avLst/>
+            </a:prstGeom>
+            <a:solidFill>
+              <a:srgbClr val="F2F2F2"/>
+            </a:solidFill>
+            <a:ln>
+              <a:solidFill>
+                <a:schemeClr val="tx1"/>
+              </a:solidFill>
+            </a:ln>
+          </p:spPr>
+          <p:style>
+            <a:lnRef idx="2">
+              <a:schemeClr val="accent1">
+                <a:shade val="15000"/>
+              </a:schemeClr>
+            </a:lnRef>
+            <a:fillRef idx="1">
+              <a:schemeClr val="accent1"/>
+            </a:fillRef>
+            <a:effectRef idx="0">
+              <a:schemeClr val="accent1"/>
+            </a:effectRef>
+            <a:fontRef idx="minor">
+              <a:schemeClr val="lt1"/>
+            </a:fontRef>
+          </p:style>
+          <p:txBody>
+            <a:bodyPr rtlCol="0" anchor="ctr"/>
+            <a:lstStyle/>
+            <a:p>
+              <a:pPr algn="ctr"/>
+              <a:r>
+                <a:rPr lang="en-US" sz="3600" dirty="0">
+                  <a:solidFill>
+                    <a:schemeClr val="tx1"/>
+                  </a:solidFill>
+                  <a:latin typeface="Tahoma" panose="020B0604030504040204" pitchFamily="34" charset="0"/>
+                  <a:ea typeface="Tahoma" panose="020B0604030504040204" pitchFamily="34" charset="0"/>
+                  <a:cs typeface="Tahoma" panose="020B0604030504040204" pitchFamily="34" charset="0"/>
+                </a:rPr>
+                <a:t>H</a:t>
+              </a:r>
+            </a:p>
+          </p:txBody>
+        </p:sp>
+        <p:cxnSp>
+          <p:nvCxnSpPr>
+            <p:cNvPr id="23" name="Straight Connector 22">
+              <a:extLst>
+                <a:ext uri="{FF2B5EF4-FFF2-40B4-BE49-F238E27FC236}">
+                  <a16:creationId xmlns:a16="http://schemas.microsoft.com/office/drawing/2014/main" id="{18C94983-595E-4B47-3357-348526FA0FB8}"/>
+                </a:ext>
+              </a:extLst>
+            </p:cNvPr>
+            <p:cNvCxnSpPr>
+              <a:cxnSpLocks/>
+            </p:cNvCxnSpPr>
+            <p:nvPr/>
+          </p:nvCxnSpPr>
+          <p:spPr>
+            <a:xfrm flipH="1" flipV="1">
+              <a:off x="4634202" y="2201101"/>
+              <a:ext cx="1755554" cy="1419922"/>
+            </a:xfrm>
+            <a:prstGeom prst="line">
+              <a:avLst/>
+            </a:prstGeom>
+            <a:ln w="38100"/>
+          </p:spPr>
+          <p:style>
+            <a:lnRef idx="2">
+              <a:schemeClr val="dk1"/>
+            </a:lnRef>
+            <a:fillRef idx="0">
+              <a:schemeClr val="dk1"/>
+            </a:fillRef>
+            <a:effectRef idx="1">
+              <a:schemeClr val="dk1"/>
+            </a:effectRef>
+            <a:fontRef idx="minor">
+              <a:schemeClr val="tx1"/>
+            </a:fontRef>
+          </p:style>
+        </p:cxnSp>
+        <p:sp>
+          <p:nvSpPr>
+            <p:cNvPr id="24" name="Oval 23">
+              <a:extLst>
+                <a:ext uri="{FF2B5EF4-FFF2-40B4-BE49-F238E27FC236}">
+                  <a16:creationId xmlns:a16="http://schemas.microsoft.com/office/drawing/2014/main" id="{153C7F94-AE14-C825-0F86-BA1FC1E9CD19}"/>
+                </a:ext>
+              </a:extLst>
+            </p:cNvPr>
+            <p:cNvSpPr/>
+            <p:nvPr/>
+          </p:nvSpPr>
+          <p:spPr>
+            <a:xfrm>
+              <a:off x="4197129" y="1735993"/>
+              <a:ext cx="874146" cy="930217"/>
+            </a:xfrm>
+            <a:prstGeom prst="ellipse">
+              <a:avLst/>
+            </a:prstGeom>
+            <a:solidFill>
+              <a:srgbClr val="8826C5"/>
+            </a:solidFill>
+          </p:spPr>
+          <p:style>
+            <a:lnRef idx="2">
+              <a:schemeClr val="accent1">
+                <a:shade val="15000"/>
+              </a:schemeClr>
+            </a:lnRef>
+            <a:fillRef idx="1">
+              <a:schemeClr val="accent1"/>
+            </a:fillRef>
+            <a:effectRef idx="0">
+              <a:schemeClr val="accent1"/>
+            </a:effectRef>
+            <a:fontRef idx="minor">
+              <a:schemeClr val="lt1"/>
+            </a:fontRef>
+          </p:style>
+          <p:txBody>
+            <a:bodyPr rtlCol="0" anchor="ctr"/>
+            <a:lstStyle/>
+            <a:p>
+              <a:pPr algn="ctr"/>
+              <a:r>
+                <a:rPr lang="en-US" sz="3600" dirty="0">
+                  <a:solidFill>
+                    <a:schemeClr val="tx1"/>
+                  </a:solidFill>
+                  <a:latin typeface="Tahoma" panose="020B0604030504040204" pitchFamily="34" charset="0"/>
+                  <a:ea typeface="Tahoma" panose="020B0604030504040204" pitchFamily="34" charset="0"/>
+                  <a:cs typeface="Tahoma" panose="020B0604030504040204" pitchFamily="34" charset="0"/>
+                </a:rPr>
+                <a:t>P</a:t>
+              </a:r>
+            </a:p>
+          </p:txBody>
+        </p:sp>
+        <p:sp>
+          <p:nvSpPr>
+            <p:cNvPr id="10" name="Oval 9">
+              <a:extLst>
+                <a:ext uri="{FF2B5EF4-FFF2-40B4-BE49-F238E27FC236}">
+                  <a16:creationId xmlns:a16="http://schemas.microsoft.com/office/drawing/2014/main" id="{A7F54FCE-EB27-CE40-B532-3B142060A817}"/>
+                </a:ext>
+              </a:extLst>
+            </p:cNvPr>
+            <p:cNvSpPr/>
+            <p:nvPr/>
+          </p:nvSpPr>
+          <p:spPr>
+            <a:xfrm>
+              <a:off x="5952683" y="3155915"/>
+              <a:ext cx="874146" cy="930217"/>
+            </a:xfrm>
+            <a:prstGeom prst="ellipse">
+              <a:avLst/>
+            </a:prstGeom>
+            <a:solidFill>
+              <a:srgbClr val="D93528"/>
+            </a:solidFill>
+          </p:spPr>
+          <p:style>
+            <a:lnRef idx="2">
+              <a:schemeClr val="accent1">
+                <a:shade val="15000"/>
+              </a:schemeClr>
+            </a:lnRef>
+            <a:fillRef idx="1">
+              <a:schemeClr val="accent1"/>
+            </a:fillRef>
+            <a:effectRef idx="0">
+              <a:schemeClr val="accent1"/>
+            </a:effectRef>
+            <a:fontRef idx="minor">
+              <a:schemeClr val="lt1"/>
+            </a:fontRef>
+          </p:style>
+          <p:txBody>
+            <a:bodyPr rtlCol="0" anchor="ctr"/>
+            <a:lstStyle/>
+            <a:p>
+              <a:pPr algn="ctr"/>
+              <a:r>
+                <a:rPr lang="en-US" sz="3600" dirty="0">
+                  <a:solidFill>
+                    <a:schemeClr val="tx1"/>
+                  </a:solidFill>
+                  <a:latin typeface="Tahoma" panose="020B0604030504040204" pitchFamily="34" charset="0"/>
+                  <a:ea typeface="Tahoma" panose="020B0604030504040204" pitchFamily="34" charset="0"/>
+                  <a:cs typeface="Tahoma" panose="020B0604030504040204" pitchFamily="34" charset="0"/>
+                </a:rPr>
+                <a:t>O</a:t>
+              </a:r>
+            </a:p>
+          </p:txBody>
+        </p:sp>
+        <mc:AlternateContent xmlns:mc="http://schemas.openxmlformats.org/markup-compatibility/2006" xmlns:a14="http://schemas.microsoft.com/office/drawing/2010/main">
+          <mc:Choice Requires="a14">
+            <p:sp>
+              <p:nvSpPr>
+                <p:cNvPr id="44" name="TextBox 43">
+                  <a:extLst>
+                    <a:ext uri="{FF2B5EF4-FFF2-40B4-BE49-F238E27FC236}">
+                      <a16:creationId xmlns:a16="http://schemas.microsoft.com/office/drawing/2014/main" id="{B16D9865-B805-47CF-D47A-58BCCB3967A0}"/>
+                    </a:ext>
+                  </a:extLst>
+                </p:cNvPr>
+                <p:cNvSpPr txBox="1"/>
+                <p:nvPr/>
+              </p:nvSpPr>
+              <p:spPr>
+                <a:xfrm>
+                  <a:off x="5247261" y="2536757"/>
+                  <a:ext cx="1005887" cy="283502"/>
+                </a:xfrm>
+                <a:prstGeom prst="rect">
+                  <a:avLst/>
+                </a:prstGeom>
+                <a:noFill/>
+              </p:spPr>
+              <p:txBody>
+                <a:bodyPr wrap="square" rtlCol="0">
+                  <a:spAutoFit/>
+                </a:bodyPr>
+                <a:lstStyle/>
+                <a:p>
+                  <a:pPr/>
+                  <a14:m>
+                    <m:oMathPara xmlns:m="http://schemas.openxmlformats.org/officeDocument/2006/math">
+                      <m:oMath>
+                        <m:r>
+                          <a:rPr lang="en-US" sz="2400" b="0" i="0" smtClean="0">
+                            <a:latin typeface="Cambria Math" panose="02040503050406030204" pitchFamily="18" charset="0"/>
+                            <a:cs typeface="Times New Roman" panose="02020603050405020304" pitchFamily="18" charset="0"/>
+                          </a:rPr>
+                          <m:t>1.484 </m:t>
+                        </m:r>
+                        <m:r>
+                          <m:rPr>
+                            <m:sty m:val="p"/>
+                          </m:rPr>
+                          <a:rPr lang="en-US" sz="2400" b="0" i="1" smtClean="0">
+                            <a:latin typeface="Cambria Math" panose="02040503050406030204" pitchFamily="18" charset="0"/>
+                            <a:cs typeface="Times New Roman" panose="02020603050405020304" pitchFamily="18" charset="0"/>
+                          </a:rPr>
+                          <m:t>Å</m:t>
+                        </m:r>
+                      </m:oMath>
+                    </m:oMathPara>
+                  </a14:m>
+                  <a:endParaRPr lang="en-GB" sz="2400" dirty="0">
+                    <a:latin typeface="Times New Roman" panose="02020603050405020304" pitchFamily="18" charset="0"/>
+                    <a:cs typeface="Times New Roman" panose="02020603050405020304" pitchFamily="18" charset="0"/>
+                  </a:endParaRPr>
+                </a:p>
+              </p:txBody>
+            </p:sp>
+          </mc:Choice>
+          <mc:Fallback xmlns="">
+            <p:sp>
+              <p:nvSpPr>
+                <p:cNvPr id="44" name="TextBox 43">
+                  <a:extLst>
+                    <a:ext uri="{FF2B5EF4-FFF2-40B4-BE49-F238E27FC236}">
+                      <a16:creationId xmlns:a16="http://schemas.microsoft.com/office/drawing/2014/main" id="{B16D9865-B805-47CF-D47A-58BCCB3967A0}"/>
+                    </a:ext>
+                  </a:extLst>
+                </p:cNvPr>
+                <p:cNvSpPr txBox="1">
+                  <a:spLocks noRot="1" noChangeAspect="1" noMove="1" noResize="1" noEditPoints="1" noAdjustHandles="1" noChangeArrowheads="1" noChangeShapeType="1" noTextEdit="1"/>
+                </p:cNvSpPr>
+                <p:nvPr/>
+              </p:nvSpPr>
+              <p:spPr>
+                <a:xfrm>
+                  <a:off x="5247261" y="2536757"/>
+                  <a:ext cx="1005887" cy="283502"/>
+                </a:xfrm>
+                <a:prstGeom prst="rect">
+                  <a:avLst/>
+                </a:prstGeom>
+                <a:blipFill>
+                  <a:blip r:embed="rId2"/>
+                  <a:stretch>
+                    <a:fillRect/>
+                  </a:stretch>
+                </a:blipFill>
+              </p:spPr>
+              <p:txBody>
+                <a:bodyPr/>
+                <a:lstStyle/>
+                <a:p>
+                  <a:r>
+                    <a:rPr lang="en-GB">
+                      <a:noFill/>
+                    </a:rPr>
+                    <a:t> </a:t>
+                  </a:r>
+                </a:p>
+              </p:txBody>
+            </p:sp>
+          </mc:Fallback>
+        </mc:AlternateContent>
+        <mc:AlternateContent xmlns:mc="http://schemas.openxmlformats.org/markup-compatibility/2006" xmlns:a14="http://schemas.microsoft.com/office/drawing/2010/main">
+          <mc:Choice Requires="a14">
+            <p:sp>
+              <p:nvSpPr>
+                <p:cNvPr id="46" name="TextBox 45">
+                  <a:extLst>
+                    <a:ext uri="{FF2B5EF4-FFF2-40B4-BE49-F238E27FC236}">
+                      <a16:creationId xmlns:a16="http://schemas.microsoft.com/office/drawing/2014/main" id="{FD510F8C-974C-6C01-403B-FA9AFEDA2154}"/>
+                    </a:ext>
+                  </a:extLst>
+                </p:cNvPr>
+                <p:cNvSpPr txBox="1"/>
+                <p:nvPr/>
+              </p:nvSpPr>
+              <p:spPr>
+                <a:xfrm>
+                  <a:off x="3032827" y="2481544"/>
+                  <a:ext cx="1005887" cy="283502"/>
+                </a:xfrm>
+                <a:prstGeom prst="rect">
+                  <a:avLst/>
+                </a:prstGeom>
+                <a:noFill/>
+              </p:spPr>
+              <p:txBody>
+                <a:bodyPr wrap="square" rtlCol="0">
+                  <a:spAutoFit/>
+                </a:bodyPr>
+                <a:lstStyle/>
+                <a:p>
+                  <a:pPr/>
+                  <a14:m>
+                    <m:oMathPara xmlns:m="http://schemas.openxmlformats.org/officeDocument/2006/math">
+                      <m:oMath>
+                        <m:r>
+                          <a:rPr lang="en-US" sz="2400" b="0" i="0" smtClean="0">
+                            <a:latin typeface="Cambria Math" panose="02040503050406030204" pitchFamily="18" charset="0"/>
+                            <a:cs typeface="Times New Roman" panose="02020603050405020304" pitchFamily="18" charset="0"/>
+                          </a:rPr>
+                          <m:t>1.455 </m:t>
+                        </m:r>
+                        <m:r>
+                          <m:rPr>
+                            <m:sty m:val="p"/>
+                          </m:rPr>
+                          <a:rPr lang="en-US" sz="2400" b="0" i="1" smtClean="0">
+                            <a:latin typeface="Cambria Math" panose="02040503050406030204" pitchFamily="18" charset="0"/>
+                            <a:cs typeface="Times New Roman" panose="02020603050405020304" pitchFamily="18" charset="0"/>
+                          </a:rPr>
+                          <m:t>Å</m:t>
+                        </m:r>
+                      </m:oMath>
+                    </m:oMathPara>
+                  </a14:m>
+                  <a:endParaRPr lang="en-GB" sz="2400" dirty="0">
+                    <a:latin typeface="Times New Roman" panose="02020603050405020304" pitchFamily="18" charset="0"/>
+                    <a:cs typeface="Times New Roman" panose="02020603050405020304" pitchFamily="18" charset="0"/>
+                  </a:endParaRPr>
+                </a:p>
+              </p:txBody>
+            </p:sp>
+          </mc:Choice>
+          <mc:Fallback xmlns="">
+            <p:sp>
+              <p:nvSpPr>
+                <p:cNvPr id="46" name="TextBox 45">
+                  <a:extLst>
+                    <a:ext uri="{FF2B5EF4-FFF2-40B4-BE49-F238E27FC236}">
+                      <a16:creationId xmlns:a16="http://schemas.microsoft.com/office/drawing/2014/main" id="{FD510F8C-974C-6C01-403B-FA9AFEDA2154}"/>
+                    </a:ext>
+                  </a:extLst>
+                </p:cNvPr>
+                <p:cNvSpPr txBox="1">
+                  <a:spLocks noRot="1" noChangeAspect="1" noMove="1" noResize="1" noEditPoints="1" noAdjustHandles="1" noChangeArrowheads="1" noChangeShapeType="1" noTextEdit="1"/>
+                </p:cNvSpPr>
+                <p:nvPr/>
+              </p:nvSpPr>
+              <p:spPr>
+                <a:xfrm>
+                  <a:off x="3032827" y="2481544"/>
+                  <a:ext cx="1005887" cy="283502"/>
+                </a:xfrm>
+                <a:prstGeom prst="rect">
+                  <a:avLst/>
+                </a:prstGeom>
+                <a:blipFill>
+                  <a:blip r:embed="rId3"/>
+                  <a:stretch>
+                    <a:fillRect/>
+                  </a:stretch>
+                </a:blipFill>
+              </p:spPr>
+              <p:txBody>
+                <a:bodyPr/>
+                <a:lstStyle/>
+                <a:p>
+                  <a:r>
+                    <a:rPr lang="en-GB">
+                      <a:noFill/>
+                    </a:rPr>
+                    <a:t> </a:t>
+                  </a:r>
+                </a:p>
+              </p:txBody>
+            </p:sp>
+          </mc:Fallback>
+        </mc:AlternateContent>
+        <mc:AlternateContent xmlns:mc="http://schemas.openxmlformats.org/markup-compatibility/2006" xmlns:a14="http://schemas.microsoft.com/office/drawing/2010/main">
+          <mc:Choice Requires="a14">
+            <p:sp>
+              <p:nvSpPr>
+                <p:cNvPr id="49" name="TextBox 48">
+                  <a:extLst>
+                    <a:ext uri="{FF2B5EF4-FFF2-40B4-BE49-F238E27FC236}">
+                      <a16:creationId xmlns:a16="http://schemas.microsoft.com/office/drawing/2014/main" id="{2D02E829-C8AA-E5E7-8819-945B2B4170E4}"/>
+                    </a:ext>
+                  </a:extLst>
+                </p:cNvPr>
+                <p:cNvSpPr txBox="1"/>
+                <p:nvPr/>
+              </p:nvSpPr>
+              <p:spPr>
+                <a:xfrm>
+                  <a:off x="4175413" y="2932664"/>
+                  <a:ext cx="1005887" cy="272671"/>
+                </a:xfrm>
+                <a:prstGeom prst="rect">
+                  <a:avLst/>
+                </a:prstGeom>
+                <a:noFill/>
+              </p:spPr>
+              <p:txBody>
+                <a:bodyPr wrap="square" rtlCol="0">
+                  <a:spAutoFit/>
+                </a:bodyPr>
+                <a:lstStyle/>
+                <a:p>
+                  <a:pPr/>
+                  <a14:m>
+                    <m:oMathPara xmlns:m="http://schemas.openxmlformats.org/officeDocument/2006/math">
+                      <m:oMath>
+                        <m:sSup>
+                          <m:sSupPr>
+                            <m:ctrlPr>
+                              <a:rPr lang="en-US" sz="2400" b="0" i="1" smtClean="0">
+                                <a:latin typeface="Cambria Math" panose="02040503050406030204" pitchFamily="18" charset="0"/>
+                                <a:cs typeface="Times New Roman" panose="02020603050405020304" pitchFamily="18" charset="0"/>
+                              </a:rPr>
+                            </m:ctrlPr>
+                          </m:sSupPr>
+                          <m:e>
+                            <m:r>
+                              <a:rPr lang="en-US" sz="2400" b="0" i="1" smtClean="0">
+                                <a:latin typeface="Cambria Math" panose="02040503050406030204" pitchFamily="18" charset="0"/>
+                                <a:cs typeface="Times New Roman" panose="02020603050405020304" pitchFamily="18" charset="0"/>
+                              </a:rPr>
+                              <m:t>104.4</m:t>
+                            </m:r>
+                          </m:e>
+                          <m:sup>
+                            <m:r>
+                              <a:rPr lang="en-US" sz="2400" b="0" i="1" smtClean="0">
+                                <a:latin typeface="Cambria Math" panose="02040503050406030204" pitchFamily="18" charset="0"/>
+                                <a:cs typeface="Times New Roman" panose="02020603050405020304" pitchFamily="18" charset="0"/>
+                              </a:rPr>
+                              <m:t>∘</m:t>
+                            </m:r>
+                          </m:sup>
+                        </m:sSup>
+                      </m:oMath>
+                    </m:oMathPara>
+                  </a14:m>
+                  <a:endParaRPr lang="en-GB" sz="2400" dirty="0">
+                    <a:latin typeface="Times New Roman" panose="02020603050405020304" pitchFamily="18" charset="0"/>
+                    <a:cs typeface="Times New Roman" panose="02020603050405020304" pitchFamily="18" charset="0"/>
+                  </a:endParaRPr>
+                </a:p>
+              </p:txBody>
+            </p:sp>
+          </mc:Choice>
+          <mc:Fallback xmlns="">
+            <p:sp>
+              <p:nvSpPr>
+                <p:cNvPr id="49" name="TextBox 48">
+                  <a:extLst>
+                    <a:ext uri="{FF2B5EF4-FFF2-40B4-BE49-F238E27FC236}">
+                      <a16:creationId xmlns:a16="http://schemas.microsoft.com/office/drawing/2014/main" id="{2D02E829-C8AA-E5E7-8819-945B2B4170E4}"/>
+                    </a:ext>
+                  </a:extLst>
+                </p:cNvPr>
+                <p:cNvSpPr txBox="1">
+                  <a:spLocks noRot="1" noChangeAspect="1" noMove="1" noResize="1" noEditPoints="1" noAdjustHandles="1" noChangeArrowheads="1" noChangeShapeType="1" noTextEdit="1"/>
+                </p:cNvSpPr>
+                <p:nvPr/>
+              </p:nvSpPr>
+              <p:spPr>
+                <a:xfrm>
+                  <a:off x="4175413" y="2932664"/>
+                  <a:ext cx="1005887" cy="272671"/>
+                </a:xfrm>
+                <a:prstGeom prst="rect">
+                  <a:avLst/>
+                </a:prstGeom>
+                <a:blipFill>
+                  <a:blip r:embed="rId4"/>
+                  <a:stretch>
+                    <a:fillRect/>
+                  </a:stretch>
+                </a:blipFill>
+              </p:spPr>
+              <p:txBody>
+                <a:bodyPr/>
+                <a:lstStyle/>
+                <a:p>
+                  <a:r>
+                    <a:rPr lang="en-GB">
+                      <a:noFill/>
+                    </a:rPr>
+                    <a:t> </a:t>
+                  </a:r>
+                </a:p>
+              </p:txBody>
+            </p:sp>
+          </mc:Fallback>
+        </mc:AlternateContent>
+      </p:grpSp>
+    </p:spTree>
+    <p:extLst>
+      <p:ext uri="{BB962C8B-B14F-4D97-AF65-F5344CB8AC3E}">
+        <p14:creationId xmlns:p14="http://schemas.microsoft.com/office/powerpoint/2010/main" val="2699379521"/>
+      </p:ext>
+    </p:extLst>
+  </p:cSld>
+  <p:clrMapOvr>
+    <a:masterClrMapping/>
+  </p:clrMapOvr>
+</p:sld>
+</file>
+
+<file path=ppt/slides/slide2.xml><?xml version="1.0" encoding="utf-8"?>
+<p:sld xmlns:a="http://schemas.openxmlformats.org/drawingml/2006/main" xmlns:r="http://schemas.openxmlformats.org/officeDocument/2006/relationships" xmlns:p="http://schemas.openxmlformats.org/presentationml/2006/main">
+  <p:cSld>
+    <p:spTree>
+      <p:nvGrpSpPr>
+        <p:cNvPr id="1" name="">
+          <a:extLst>
+            <a:ext uri="{FF2B5EF4-FFF2-40B4-BE49-F238E27FC236}">
+              <a16:creationId xmlns:a16="http://schemas.microsoft.com/office/drawing/2014/main" id="{C6AD574A-F2CE-0DD2-3CC6-284891751D07}"/>
+            </a:ext>
+          </a:extLst>
+        </p:cNvPr>
+        <p:cNvGrpSpPr/>
+        <p:nvPr/>
+      </p:nvGrpSpPr>
+      <p:grpSpPr>
+        <a:xfrm>
+          <a:off x="0" y="0"/>
+          <a:ext cx="0" cy="0"/>
+          <a:chOff x="0" y="0"/>
+          <a:chExt cx="0" cy="0"/>
+        </a:xfrm>
+      </p:grpSpPr>
       <p:sp>
         <p:nvSpPr>
           <p:cNvPr id="47" name="Arc 46">
             <a:extLst>
               <a:ext uri="{FF2B5EF4-FFF2-40B4-BE49-F238E27FC236}">
-                <a16:creationId xmlns:a16="http://schemas.microsoft.com/office/drawing/2014/main" id="{5A0802CB-0934-7C5F-3F85-9C5B47DC1B39}"/>
+                <a16:creationId xmlns:a16="http://schemas.microsoft.com/office/drawing/2014/main" id="{E00A34CF-8AA1-2586-DF2E-3398498B3F66}"/>
               </a:ext>
             </a:extLst>
           </p:cNvPr>
@@ -3355,9 +4322,9 @@
           <p:nvPr/>
         </p:nvSpPr>
         <p:spPr>
-          <a:xfrm rot="8449048">
-            <a:off x="3917299" y="1485419"/>
-            <a:ext cx="1451378" cy="1431365"/>
+          <a:xfrm rot="5144585">
+            <a:off x="3582434" y="1481558"/>
+            <a:ext cx="2457356" cy="2423472"/>
           </a:xfrm>
           <a:prstGeom prst="arc">
             <a:avLst>
@@ -3365,7 +4332,7 @@
               <a:gd name="adj2" fmla="val 21546438"/>
             </a:avLst>
           </a:prstGeom>
-          <a:ln>
+          <a:ln w="38100">
             <a:solidFill>
               <a:srgbClr val="FF0000"/>
             </a:solidFill>
@@ -3390,7 +4357,7 @@
           <a:lstStyle/>
           <a:p>
             <a:pPr algn="ctr"/>
-            <a:endParaRPr lang="en-GB"/>
+            <a:endParaRPr lang="en-GB" dirty="0"/>
           </a:p>
         </p:txBody>
       </p:sp>
@@ -3399,7 +4366,7 @@
           <p:cNvPr id="11" name="Straight Connector 10">
             <a:extLst>
               <a:ext uri="{FF2B5EF4-FFF2-40B4-BE49-F238E27FC236}">
-                <a16:creationId xmlns:a16="http://schemas.microsoft.com/office/drawing/2014/main" id="{737CFC80-10DC-AA9D-1519-BB19326C3974}"/>
+                <a16:creationId xmlns:a16="http://schemas.microsoft.com/office/drawing/2014/main" id="{D53ADA0E-5BF2-20F8-24B9-306BCEC2A521}"/>
               </a:ext>
             </a:extLst>
           </p:cNvPr>
@@ -3410,12 +4377,13 @@
         </p:nvCxnSpPr>
         <p:spPr>
           <a:xfrm flipV="1">
-            <a:off x="2966957" y="2201101"/>
-            <a:ext cx="1667245" cy="1419922"/>
+            <a:off x="4937969" y="1686675"/>
+            <a:ext cx="3099643" cy="1010479"/>
           </a:xfrm>
           <a:prstGeom prst="line">
             <a:avLst/>
           </a:prstGeom>
+          <a:ln w="38100"/>
         </p:spPr>
         <p:style>
           <a:lnRef idx="2">
@@ -3437,7 +4405,7 @@
           <p:cNvPr id="22" name="Oval 21">
             <a:extLst>
               <a:ext uri="{FF2B5EF4-FFF2-40B4-BE49-F238E27FC236}">
-                <a16:creationId xmlns:a16="http://schemas.microsoft.com/office/drawing/2014/main" id="{3AD5A7CD-FFA7-1C22-ECDD-3CC12CC49CFF}"/>
+                <a16:creationId xmlns:a16="http://schemas.microsoft.com/office/drawing/2014/main" id="{15F66337-BA7C-C813-B682-C1B81815E3D1}"/>
               </a:ext>
             </a:extLst>
           </p:cNvPr>
@@ -3446,8 +4414,8 @@
         </p:nvSpPr>
         <p:spPr>
           <a:xfrm>
-            <a:off x="2529884" y="3146770"/>
-            <a:ext cx="874146" cy="930217"/>
+            <a:off x="7297596" y="899191"/>
+            <a:ext cx="1480033" cy="1574968"/>
           </a:xfrm>
           <a:prstGeom prst="ellipse">
             <a:avLst/>
@@ -3483,7 +4451,7 @@
           <a:p>
             <a:pPr algn="ctr"/>
             <a:r>
-              <a:rPr lang="en-US" sz="3200" dirty="0">
+              <a:rPr lang="en-US" sz="3600" dirty="0">
                 <a:solidFill>
                   <a:schemeClr val="tx1"/>
                 </a:solidFill>
@@ -3501,7 +4469,7 @@
           <p:cNvPr id="23" name="Straight Connector 22">
             <a:extLst>
               <a:ext uri="{FF2B5EF4-FFF2-40B4-BE49-F238E27FC236}">
-                <a16:creationId xmlns:a16="http://schemas.microsoft.com/office/drawing/2014/main" id="{18C94983-595E-4B47-3357-348526FA0FB8}"/>
+                <a16:creationId xmlns:a16="http://schemas.microsoft.com/office/drawing/2014/main" id="{0F295CC0-DBF8-EFC2-9AF0-828D01A890F9}"/>
               </a:ext>
             </a:extLst>
           </p:cNvPr>
@@ -3512,12 +4480,13 @@
         </p:nvCxnSpPr>
         <p:spPr>
           <a:xfrm flipH="1" flipV="1">
-            <a:off x="4634202" y="2201101"/>
-            <a:ext cx="1755554" cy="1419922"/>
+            <a:off x="4931455" y="2697154"/>
+            <a:ext cx="6514" cy="2926406"/>
           </a:xfrm>
           <a:prstGeom prst="line">
             <a:avLst/>
           </a:prstGeom>
+          <a:ln w="38100"/>
         </p:spPr>
         <p:style>
           <a:lnRef idx="2">
@@ -3539,7 +4508,7 @@
           <p:cNvPr id="24" name="Oval 23">
             <a:extLst>
               <a:ext uri="{FF2B5EF4-FFF2-40B4-BE49-F238E27FC236}">
-                <a16:creationId xmlns:a16="http://schemas.microsoft.com/office/drawing/2014/main" id="{153C7F94-AE14-C825-0F86-BA1FC1E9CD19}"/>
+                <a16:creationId xmlns:a16="http://schemas.microsoft.com/office/drawing/2014/main" id="{280447AB-28FE-B511-8F76-F72F2704CC20}"/>
               </a:ext>
             </a:extLst>
           </p:cNvPr>
@@ -3548,8 +4517,8 @@
         </p:nvSpPr>
         <p:spPr>
           <a:xfrm>
-            <a:off x="4197129" y="1735993"/>
-            <a:ext cx="874146" cy="930217"/>
+            <a:off x="4191440" y="1909671"/>
+            <a:ext cx="1480033" cy="1574968"/>
           </a:xfrm>
           <a:prstGeom prst="ellipse">
             <a:avLst/>
@@ -3580,7 +4549,7 @@
           <a:p>
             <a:pPr algn="ctr"/>
             <a:r>
-              <a:rPr lang="en-US" sz="3200" dirty="0">
+              <a:rPr lang="en-US" sz="3600" dirty="0">
                 <a:solidFill>
                   <a:schemeClr val="tx1"/>
                 </a:solidFill>
@@ -3598,7 +4567,7 @@
           <p:cNvPr id="10" name="Oval 9">
             <a:extLst>
               <a:ext uri="{FF2B5EF4-FFF2-40B4-BE49-F238E27FC236}">
-                <a16:creationId xmlns:a16="http://schemas.microsoft.com/office/drawing/2014/main" id="{A7F54FCE-EB27-CE40-B532-3B142060A817}"/>
+                <a16:creationId xmlns:a16="http://schemas.microsoft.com/office/drawing/2014/main" id="{38EF4465-53E9-89D7-ECDB-5EF19EE4809D}"/>
               </a:ext>
             </a:extLst>
           </p:cNvPr>
@@ -3607,8 +4576,8 @@
         </p:nvSpPr>
         <p:spPr>
           <a:xfrm>
-            <a:off x="5952683" y="3155915"/>
-            <a:ext cx="874146" cy="930217"/>
+            <a:off x="4191439" y="4751015"/>
+            <a:ext cx="1480033" cy="1574968"/>
           </a:xfrm>
           <a:prstGeom prst="ellipse">
             <a:avLst/>
@@ -3639,7 +4608,7 @@
           <a:p>
             <a:pPr algn="ctr"/>
             <a:r>
-              <a:rPr lang="en-US" sz="3200" dirty="0">
+              <a:rPr lang="en-US" sz="3600" dirty="0">
                 <a:solidFill>
                   <a:schemeClr val="tx1"/>
                 </a:solidFill>
@@ -3656,10 +4625,10 @@
         <mc:Choice xmlns:a14="http://schemas.microsoft.com/office/drawing/2010/main" Requires="a14">
           <p:sp>
             <p:nvSpPr>
-              <p:cNvPr id="44" name="TextBox 43">
+              <p:cNvPr id="9" name="TextBox 8">
                 <a:extLst>
                   <a:ext uri="{FF2B5EF4-FFF2-40B4-BE49-F238E27FC236}">
-                    <a16:creationId xmlns:a16="http://schemas.microsoft.com/office/drawing/2014/main" id="{B16D9865-B805-47CF-D47A-58BCCB3967A0}"/>
+                    <a16:creationId xmlns:a16="http://schemas.microsoft.com/office/drawing/2014/main" id="{B0B6BFB7-7EFB-DDC3-6926-0EB97780D9CC}"/>
                   </a:ext>
                 </a:extLst>
               </p:cNvPr>
@@ -3668,8 +4637,8 @@
             </p:nvSpPr>
             <p:spPr>
               <a:xfrm>
-                <a:off x="5295560" y="2481544"/>
-                <a:ext cx="1005887" cy="383118"/>
+                <a:off x="3728498" y="3670814"/>
+                <a:ext cx="1703087" cy="584775"/>
               </a:xfrm>
               <a:prstGeom prst="rect">
                 <a:avLst/>
@@ -3682,30 +4651,42 @@
               </a:bodyPr>
               <a:lstStyle/>
               <a:p>
+                <a:pPr/>
                 <a14:m>
                   <m:oMathPara xmlns:m="http://schemas.openxmlformats.org/officeDocument/2006/math">
-                    <m:oMathParaPr>
-                      <m:jc m:val="centerGroup"/>
-                    </m:oMathParaPr>
-                    <m:oMath xmlns:m="http://schemas.openxmlformats.org/officeDocument/2006/math">
-                      <m:r>
-                        <a:rPr lang="en-US" b="0" i="0" smtClean="0">
-                          <a:latin typeface="Cambria Math" panose="02040503050406030204" pitchFamily="18" charset="0"/>
-                          <a:cs typeface="Times New Roman" panose="02020603050405020304" pitchFamily="18" charset="0"/>
-                        </a:rPr>
-                        <m:t>1.484 </m:t>
-                      </m:r>
-                      <m:r>
-                        <a:rPr lang="en-US" b="0" i="1" smtClean="0">
-                          <a:latin typeface="Cambria Math" panose="02040503050406030204" pitchFamily="18" charset="0"/>
-                          <a:cs typeface="Times New Roman" panose="02020603050405020304" pitchFamily="18" charset="0"/>
-                        </a:rPr>
-                        <m:t>Å</m:t>
-                      </m:r>
+                    <m:oMath>
+                      <m:sSub>
+                        <m:sSubPr>
+                          <m:ctrlPr>
+                            <a:rPr lang="en-US" sz="3200" b="0" i="1" smtClean="0">
+                              <a:latin typeface="Cambria Math" panose="02040503050406030204" pitchFamily="18" charset="0"/>
+                              <a:cs typeface="Times New Roman" panose="02020603050405020304" pitchFamily="18" charset="0"/>
+                            </a:rPr>
+                          </m:ctrlPr>
+                        </m:sSubPr>
+                        <m:e>
+                          <m:r>
+                            <a:rPr lang="en-US" sz="3200" b="0" i="1" smtClean="0">
+                              <a:latin typeface="Cambria Math" panose="02040503050406030204" pitchFamily="18" charset="0"/>
+                              <a:cs typeface="Times New Roman" panose="02020603050405020304" pitchFamily="18" charset="0"/>
+                            </a:rPr>
+                            <m:t>𝑟</m:t>
+                          </m:r>
+                        </m:e>
+                        <m:sub>
+                          <m:r>
+                            <a:rPr lang="en-US" sz="3200" b="0" i="1" smtClean="0">
+                              <a:latin typeface="Cambria Math" panose="02040503050406030204" pitchFamily="18" charset="0"/>
+                              <a:cs typeface="Times New Roman" panose="02020603050405020304" pitchFamily="18" charset="0"/>
+                            </a:rPr>
+                            <m:t>1</m:t>
+                          </m:r>
+                        </m:sub>
+                      </m:sSub>
                     </m:oMath>
                   </m:oMathPara>
                 </a14:m>
-                <a:endParaRPr lang="en-GB" dirty="0">
+                <a:endParaRPr lang="en-GB" sz="3200" dirty="0">
                   <a:latin typeface="Times New Roman" panose="02020603050405020304" pitchFamily="18" charset="0"/>
                   <a:cs typeface="Times New Roman" panose="02020603050405020304" pitchFamily="18" charset="0"/>
                 </a:endParaRPr>
@@ -3716,10 +4697,10 @@
         <mc:Fallback>
           <p:sp>
             <p:nvSpPr>
-              <p:cNvPr id="44" name="TextBox 43">
+              <p:cNvPr id="9" name="TextBox 8">
                 <a:extLst>
                   <a:ext uri="{FF2B5EF4-FFF2-40B4-BE49-F238E27FC236}">
-                    <a16:creationId xmlns:a16="http://schemas.microsoft.com/office/drawing/2014/main" id="{B16D9865-B805-47CF-D47A-58BCCB3967A0}"/>
+                    <a16:creationId xmlns:a16="http://schemas.microsoft.com/office/drawing/2014/main" id="{B0B6BFB7-7EFB-DDC3-6926-0EB97780D9CC}"/>
                   </a:ext>
                 </a:extLst>
               </p:cNvPr>
@@ -3730,8 +4711,8 @@
             </p:nvSpPr>
             <p:spPr>
               <a:xfrm>
-                <a:off x="5295560" y="2481544"/>
-                <a:ext cx="1005887" cy="383118"/>
+                <a:off x="3728498" y="3670814"/>
+                <a:ext cx="1703087" cy="584775"/>
               </a:xfrm>
               <a:prstGeom prst="rect">
                 <a:avLst/>
@@ -3739,7 +4720,7 @@
               <a:blipFill>
                 <a:blip r:embed="rId2"/>
                 <a:stretch>
-                  <a:fillRect b="-1587"/>
+                  <a:fillRect/>
                 </a:stretch>
               </a:blipFill>
             </p:spPr>
@@ -3762,10 +4743,10 @@
         <mc:Choice xmlns:a14="http://schemas.microsoft.com/office/drawing/2010/main" Requires="a14">
           <p:sp>
             <p:nvSpPr>
-              <p:cNvPr id="46" name="TextBox 45">
+              <p:cNvPr id="13" name="TextBox 12">
                 <a:extLst>
                   <a:ext uri="{FF2B5EF4-FFF2-40B4-BE49-F238E27FC236}">
-                    <a16:creationId xmlns:a16="http://schemas.microsoft.com/office/drawing/2014/main" id="{FD510F8C-974C-6C01-403B-FA9AFEDA2154}"/>
+                    <a16:creationId xmlns:a16="http://schemas.microsoft.com/office/drawing/2014/main" id="{FD075C99-06C4-26D6-83AD-AD6C788886EF}"/>
                   </a:ext>
                 </a:extLst>
               </p:cNvPr>
@@ -3774,8 +4755,8 @@
             </p:nvSpPr>
             <p:spPr>
               <a:xfrm>
-                <a:off x="2972705" y="2420126"/>
-                <a:ext cx="1005887" cy="383118"/>
+                <a:off x="5449922" y="1500500"/>
+                <a:ext cx="1703087" cy="584775"/>
               </a:xfrm>
               <a:prstGeom prst="rect">
                 <a:avLst/>
@@ -3791,35 +4772,39 @@
                 <a:pPr/>
                 <a14:m>
                   <m:oMathPara xmlns:m="http://schemas.openxmlformats.org/officeDocument/2006/math">
-                    <m:oMathParaPr>
-                      <m:jc m:val="centerGroup"/>
-                    </m:oMathParaPr>
-                    <m:oMath xmlns:m="http://schemas.openxmlformats.org/officeDocument/2006/math">
-                      <m:r>
-                        <a:rPr lang="en-US" b="0" i="0" smtClean="0">
-                          <a:latin typeface="Cambria Math" panose="02040503050406030204" pitchFamily="18" charset="0"/>
-                          <a:cs typeface="Times New Roman" panose="02020603050405020304" pitchFamily="18" charset="0"/>
-                        </a:rPr>
-                        <m:t>1.455</m:t>
-                      </m:r>
-                      <m:r>
-                        <a:rPr lang="en-US" b="0" i="0" smtClean="0">
-                          <a:latin typeface="Cambria Math" panose="02040503050406030204" pitchFamily="18" charset="0"/>
-                          <a:cs typeface="Times New Roman" panose="02020603050405020304" pitchFamily="18" charset="0"/>
-                        </a:rPr>
-                        <m:t> </m:t>
-                      </m:r>
-                      <m:r>
-                        <a:rPr lang="en-US" b="0" i="1" smtClean="0">
-                          <a:latin typeface="Cambria Math" panose="02040503050406030204" pitchFamily="18" charset="0"/>
-                          <a:cs typeface="Times New Roman" panose="02020603050405020304" pitchFamily="18" charset="0"/>
-                        </a:rPr>
-                        <m:t>Å</m:t>
-                      </m:r>
+                    <m:oMath>
+                      <m:sSub>
+                        <m:sSubPr>
+                          <m:ctrlPr>
+                            <a:rPr lang="en-US" sz="3200" b="0" i="1" smtClean="0">
+                              <a:latin typeface="Cambria Math" panose="02040503050406030204" pitchFamily="18" charset="0"/>
+                              <a:cs typeface="Times New Roman" panose="02020603050405020304" pitchFamily="18" charset="0"/>
+                            </a:rPr>
+                          </m:ctrlPr>
+                        </m:sSubPr>
+                        <m:e>
+                          <m:r>
+                            <a:rPr lang="en-US" sz="3200" b="0" i="1" smtClean="0">
+                              <a:latin typeface="Cambria Math" panose="02040503050406030204" pitchFamily="18" charset="0"/>
+                              <a:cs typeface="Times New Roman" panose="02020603050405020304" pitchFamily="18" charset="0"/>
+                            </a:rPr>
+                            <m:t>𝑟</m:t>
+                          </m:r>
+                        </m:e>
+                        <m:sub>
+                          <m:r>
+                            <a:rPr lang="en-US" sz="3200" b="0" i="1" smtClean="0">
+                              <a:latin typeface="Cambria Math" panose="02040503050406030204" pitchFamily="18" charset="0"/>
+                              <a:cs typeface="Times New Roman" panose="02020603050405020304" pitchFamily="18" charset="0"/>
+                            </a:rPr>
+                            <m:t>2</m:t>
+                          </m:r>
+                        </m:sub>
+                      </m:sSub>
                     </m:oMath>
                   </m:oMathPara>
                 </a14:m>
-                <a:endParaRPr lang="en-GB" dirty="0">
+                <a:endParaRPr lang="en-GB" sz="3200" dirty="0">
                   <a:latin typeface="Times New Roman" panose="02020603050405020304" pitchFamily="18" charset="0"/>
                   <a:cs typeface="Times New Roman" panose="02020603050405020304" pitchFamily="18" charset="0"/>
                 </a:endParaRPr>
@@ -3830,10 +4815,10 @@
         <mc:Fallback>
           <p:sp>
             <p:nvSpPr>
-              <p:cNvPr id="46" name="TextBox 45">
+              <p:cNvPr id="13" name="TextBox 12">
                 <a:extLst>
                   <a:ext uri="{FF2B5EF4-FFF2-40B4-BE49-F238E27FC236}">
-                    <a16:creationId xmlns:a16="http://schemas.microsoft.com/office/drawing/2014/main" id="{FD510F8C-974C-6C01-403B-FA9AFEDA2154}"/>
+                    <a16:creationId xmlns:a16="http://schemas.microsoft.com/office/drawing/2014/main" id="{FD075C99-06C4-26D6-83AD-AD6C788886EF}"/>
                   </a:ext>
                 </a:extLst>
               </p:cNvPr>
@@ -3844,8 +4829,8 @@
             </p:nvSpPr>
             <p:spPr>
               <a:xfrm>
-                <a:off x="2972705" y="2420126"/>
-                <a:ext cx="1005887" cy="383118"/>
+                <a:off x="5449922" y="1500500"/>
+                <a:ext cx="1703087" cy="584775"/>
               </a:xfrm>
               <a:prstGeom prst="rect">
                 <a:avLst/>
@@ -3853,7 +4838,7 @@
               <a:blipFill>
                 <a:blip r:embed="rId3"/>
                 <a:stretch>
-                  <a:fillRect b="-1587"/>
+                  <a:fillRect/>
                 </a:stretch>
               </a:blipFill>
             </p:spPr>
@@ -3876,10 +4861,10 @@
         <mc:Choice xmlns:a14="http://schemas.microsoft.com/office/drawing/2010/main" Requires="a14">
           <p:sp>
             <p:nvSpPr>
-              <p:cNvPr id="49" name="TextBox 48">
+              <p:cNvPr id="15" name="TextBox 14">
                 <a:extLst>
                   <a:ext uri="{FF2B5EF4-FFF2-40B4-BE49-F238E27FC236}">
-                    <a16:creationId xmlns:a16="http://schemas.microsoft.com/office/drawing/2014/main" id="{2D02E829-C8AA-E5E7-8819-945B2B4170E4}"/>
+                    <a16:creationId xmlns:a16="http://schemas.microsoft.com/office/drawing/2014/main" id="{D29B6249-D196-AC9D-C6B8-018AAD065877}"/>
                   </a:ext>
                 </a:extLst>
               </p:cNvPr>
@@ -3888,8 +4873,8 @@
             </p:nvSpPr>
             <p:spPr>
               <a:xfrm>
-                <a:off x="4175413" y="2911062"/>
-                <a:ext cx="1005887" cy="369332"/>
+                <a:off x="5186681" y="3192580"/>
+                <a:ext cx="1703087" cy="584775"/>
               </a:xfrm>
               <a:prstGeom prst="rect">
                 <a:avLst/>
@@ -3905,42 +4890,18 @@
                 <a:pPr/>
                 <a14:m>
                   <m:oMathPara xmlns:m="http://schemas.openxmlformats.org/officeDocument/2006/math">
-                    <m:oMathParaPr>
-                      <m:jc m:val="centerGroup"/>
-                    </m:oMathParaPr>
-                    <m:oMath xmlns:m="http://schemas.openxmlformats.org/officeDocument/2006/math">
-                      <m:sSup>
-                        <m:sSupPr>
-                          <m:ctrlPr>
-                            <a:rPr lang="en-US" b="0" i="1" smtClean="0">
-                              <a:latin typeface="Cambria Math" panose="02040503050406030204" pitchFamily="18" charset="0"/>
-                              <a:cs typeface="Times New Roman" panose="02020603050405020304" pitchFamily="18" charset="0"/>
-                            </a:rPr>
-                          </m:ctrlPr>
-                        </m:sSupPr>
-                        <m:e>
-                          <m:r>
-                            <a:rPr lang="en-US" b="0" i="1" smtClean="0">
-                              <a:latin typeface="Cambria Math" panose="02040503050406030204" pitchFamily="18" charset="0"/>
-                              <a:cs typeface="Times New Roman" panose="02020603050405020304" pitchFamily="18" charset="0"/>
-                            </a:rPr>
-                            <m:t>104.4</m:t>
-                          </m:r>
-                        </m:e>
-                        <m:sup>
-                          <m:r>
-                            <a:rPr lang="en-US" b="0" i="1" smtClean="0">
-                              <a:latin typeface="Cambria Math" panose="02040503050406030204" pitchFamily="18" charset="0"/>
-                              <a:cs typeface="Times New Roman" panose="02020603050405020304" pitchFamily="18" charset="0"/>
-                            </a:rPr>
-                            <m:t>∘</m:t>
-                          </m:r>
-                        </m:sup>
-                      </m:sSup>
+                    <m:oMath>
+                      <m:r>
+                        <a:rPr lang="en-US" sz="3200" b="0" i="1" smtClean="0">
+                          <a:latin typeface="Cambria Math" panose="02040503050406030204" pitchFamily="18" charset="0"/>
+                          <a:cs typeface="Times New Roman" panose="02020603050405020304" pitchFamily="18" charset="0"/>
+                        </a:rPr>
+                        <m:t>𝜃</m:t>
+                      </m:r>
                     </m:oMath>
                   </m:oMathPara>
                 </a14:m>
-                <a:endParaRPr lang="en-GB" dirty="0">
+                <a:endParaRPr lang="en-GB" sz="3200" dirty="0">
                   <a:latin typeface="Times New Roman" panose="02020603050405020304" pitchFamily="18" charset="0"/>
                   <a:cs typeface="Times New Roman" panose="02020603050405020304" pitchFamily="18" charset="0"/>
                 </a:endParaRPr>
@@ -3951,10 +4912,10 @@
         <mc:Fallback>
           <p:sp>
             <p:nvSpPr>
-              <p:cNvPr id="49" name="TextBox 48">
+              <p:cNvPr id="15" name="TextBox 14">
                 <a:extLst>
                   <a:ext uri="{FF2B5EF4-FFF2-40B4-BE49-F238E27FC236}">
-                    <a16:creationId xmlns:a16="http://schemas.microsoft.com/office/drawing/2014/main" id="{2D02E829-C8AA-E5E7-8819-945B2B4170E4}"/>
+                    <a16:creationId xmlns:a16="http://schemas.microsoft.com/office/drawing/2014/main" id="{D29B6249-D196-AC9D-C6B8-018AAD065877}"/>
                   </a:ext>
                 </a:extLst>
               </p:cNvPr>
@@ -3965,8 +4926,8 @@
             </p:nvSpPr>
             <p:spPr>
               <a:xfrm>
-                <a:off x="4175413" y="2911062"/>
-                <a:ext cx="1005887" cy="369332"/>
+                <a:off x="5186681" y="3192580"/>
+                <a:ext cx="1703087" cy="584775"/>
               </a:xfrm>
               <a:prstGeom prst="rect">
                 <a:avLst/>
@@ -3993,10 +4954,323 @@
           </p:sp>
         </mc:Fallback>
       </mc:AlternateContent>
+      <p:grpSp>
+        <p:nvGrpSpPr>
+          <p:cNvPr id="20" name="Group 19">
+            <a:extLst>
+              <a:ext uri="{FF2B5EF4-FFF2-40B4-BE49-F238E27FC236}">
+                <a16:creationId xmlns:a16="http://schemas.microsoft.com/office/drawing/2014/main" id="{612D1359-D49E-F522-3580-95ACCFAD79ED}"/>
+              </a:ext>
+            </a:extLst>
+          </p:cNvPr>
+          <p:cNvGrpSpPr/>
+          <p:nvPr/>
+        </p:nvGrpSpPr>
+        <p:grpSpPr>
+          <a:xfrm>
+            <a:off x="6748363" y="3746943"/>
+            <a:ext cx="990759" cy="1022926"/>
+            <a:chOff x="6595459" y="3777355"/>
+            <a:chExt cx="990759" cy="1022926"/>
+          </a:xfrm>
+        </p:grpSpPr>
+        <p:cxnSp>
+          <p:nvCxnSpPr>
+            <p:cNvPr id="16" name="Straight Connector 15">
+              <a:extLst>
+                <a:ext uri="{FF2B5EF4-FFF2-40B4-BE49-F238E27FC236}">
+                  <a16:creationId xmlns:a16="http://schemas.microsoft.com/office/drawing/2014/main" id="{96AEE7BF-AE50-F70D-1016-7AC735D1419B}"/>
+                </a:ext>
+              </a:extLst>
+            </p:cNvPr>
+            <p:cNvCxnSpPr>
+              <a:cxnSpLocks/>
+            </p:cNvCxnSpPr>
+            <p:nvPr/>
+          </p:nvCxnSpPr>
+          <p:spPr>
+            <a:xfrm>
+              <a:off x="6601809" y="3777355"/>
+              <a:ext cx="0" cy="1022926"/>
+            </a:xfrm>
+            <a:prstGeom prst="line">
+              <a:avLst/>
+            </a:prstGeom>
+            <a:ln w="28575">
+              <a:headEnd type="triangle"/>
+            </a:ln>
+          </p:spPr>
+          <p:style>
+            <a:lnRef idx="2">
+              <a:schemeClr val="dk1"/>
+            </a:lnRef>
+            <a:fillRef idx="0">
+              <a:schemeClr val="dk1"/>
+            </a:fillRef>
+            <a:effectRef idx="1">
+              <a:schemeClr val="dk1"/>
+            </a:effectRef>
+            <a:fontRef idx="minor">
+              <a:schemeClr val="tx1"/>
+            </a:fontRef>
+          </p:style>
+        </p:cxnSp>
+        <p:cxnSp>
+          <p:nvCxnSpPr>
+            <p:cNvPr id="18" name="Straight Connector 17">
+              <a:extLst>
+                <a:ext uri="{FF2B5EF4-FFF2-40B4-BE49-F238E27FC236}">
+                  <a16:creationId xmlns:a16="http://schemas.microsoft.com/office/drawing/2014/main" id="{E4F6C35F-EC06-C35D-DB8C-CC0A42733084}"/>
+                </a:ext>
+              </a:extLst>
+            </p:cNvPr>
+            <p:cNvCxnSpPr>
+              <a:cxnSpLocks/>
+            </p:cNvCxnSpPr>
+            <p:nvPr/>
+          </p:nvCxnSpPr>
+          <p:spPr>
+            <a:xfrm flipH="1">
+              <a:off x="6595459" y="4793931"/>
+              <a:ext cx="990759" cy="0"/>
+            </a:xfrm>
+            <a:prstGeom prst="line">
+              <a:avLst/>
+            </a:prstGeom>
+            <a:ln w="28575">
+              <a:headEnd type="triangle"/>
+            </a:ln>
+          </p:spPr>
+          <p:style>
+            <a:lnRef idx="2">
+              <a:schemeClr val="dk1"/>
+            </a:lnRef>
+            <a:fillRef idx="0">
+              <a:schemeClr val="dk1"/>
+            </a:fillRef>
+            <a:effectRef idx="1">
+              <a:schemeClr val="dk1"/>
+            </a:effectRef>
+            <a:fontRef idx="minor">
+              <a:schemeClr val="tx1"/>
+            </a:fontRef>
+          </p:style>
+        </p:cxnSp>
+      </p:grpSp>
+      <mc:AlternateContent xmlns:mc="http://schemas.openxmlformats.org/markup-compatibility/2006">
+        <mc:Choice xmlns:a14="http://schemas.microsoft.com/office/drawing/2010/main" Requires="a14">
+          <p:sp>
+            <p:nvSpPr>
+              <p:cNvPr id="25" name="TextBox 24">
+                <a:extLst>
+                  <a:ext uri="{FF2B5EF4-FFF2-40B4-BE49-F238E27FC236}">
+                    <a16:creationId xmlns:a16="http://schemas.microsoft.com/office/drawing/2014/main" id="{DCAE7460-EF02-940E-C124-B9FE596D4C3B}"/>
+                  </a:ext>
+                </a:extLst>
+              </p:cNvPr>
+              <p:cNvSpPr txBox="1"/>
+              <p:nvPr/>
+            </p:nvSpPr>
+            <p:spPr>
+              <a:xfrm>
+                <a:off x="6748139" y="3523948"/>
+                <a:ext cx="687958" cy="580344"/>
+              </a:xfrm>
+              <a:prstGeom prst="rect">
+                <a:avLst/>
+              </a:prstGeom>
+              <a:noFill/>
+            </p:spPr>
+            <p:txBody>
+              <a:bodyPr wrap="square">
+                <a:spAutoFit/>
+              </a:bodyPr>
+              <a:lstStyle/>
+              <a:p>
+                <a:pPr algn="ctr"/>
+                <a14:m>
+                  <m:oMathPara xmlns:m="http://schemas.openxmlformats.org/officeDocument/2006/math">
+                    <m:oMath>
+                      <m:r>
+                        <a:rPr lang="en-US" sz="2800" b="0" i="1" smtClean="0">
+                          <a:solidFill>
+                            <a:schemeClr val="tx1"/>
+                          </a:solidFill>
+                          <a:latin typeface="Cambria Math" panose="02040503050406030204" pitchFamily="18" charset="0"/>
+                          <a:ea typeface="Tahoma" panose="020B0604030504040204" pitchFamily="34" charset="0"/>
+                          <a:cs typeface="Tahoma" panose="020B0604030504040204" pitchFamily="34" charset="0"/>
+                        </a:rPr>
+                        <m:t>𝑧</m:t>
+                      </m:r>
+                    </m:oMath>
+                  </m:oMathPara>
+                </a14:m>
+                <a:endParaRPr lang="en-US" sz="3200" dirty="0">
+                  <a:solidFill>
+                    <a:schemeClr val="tx1"/>
+                  </a:solidFill>
+                  <a:latin typeface="Tahoma" panose="020B0604030504040204" pitchFamily="34" charset="0"/>
+                  <a:ea typeface="Tahoma" panose="020B0604030504040204" pitchFamily="34" charset="0"/>
+                  <a:cs typeface="Tahoma" panose="020B0604030504040204" pitchFamily="34" charset="0"/>
+                </a:endParaRPr>
+              </a:p>
+            </p:txBody>
+          </p:sp>
+        </mc:Choice>
+        <mc:Fallback>
+          <p:sp>
+            <p:nvSpPr>
+              <p:cNvPr id="25" name="TextBox 24">
+                <a:extLst>
+                  <a:ext uri="{FF2B5EF4-FFF2-40B4-BE49-F238E27FC236}">
+                    <a16:creationId xmlns:a16="http://schemas.microsoft.com/office/drawing/2014/main" id="{DCAE7460-EF02-940E-C124-B9FE596D4C3B}"/>
+                  </a:ext>
+                </a:extLst>
+              </p:cNvPr>
+              <p:cNvSpPr txBox="1">
+                <a:spLocks noRot="1" noChangeAspect="1" noMove="1" noResize="1" noEditPoints="1" noAdjustHandles="1" noChangeArrowheads="1" noChangeShapeType="1" noTextEdit="1"/>
+              </p:cNvSpPr>
+              <p:nvPr/>
+            </p:nvSpPr>
+            <p:spPr>
+              <a:xfrm>
+                <a:off x="6748139" y="3523948"/>
+                <a:ext cx="687958" cy="580344"/>
+              </a:xfrm>
+              <a:prstGeom prst="rect">
+                <a:avLst/>
+              </a:prstGeom>
+              <a:blipFill>
+                <a:blip r:embed="rId5"/>
+                <a:stretch>
+                  <a:fillRect/>
+                </a:stretch>
+              </a:blipFill>
+            </p:spPr>
+            <p:txBody>
+              <a:bodyPr/>
+              <a:lstStyle/>
+              <a:p>
+                <a:r>
+                  <a:rPr lang="en-GB">
+                    <a:noFill/>
+                  </a:rPr>
+                  <a:t> </a:t>
+                </a:r>
+              </a:p>
+            </p:txBody>
+          </p:sp>
+        </mc:Fallback>
+      </mc:AlternateContent>
+      <mc:AlternateContent xmlns:mc="http://schemas.openxmlformats.org/markup-compatibility/2006">
+        <mc:Choice xmlns:a14="http://schemas.microsoft.com/office/drawing/2010/main" Requires="a14">
+          <p:sp>
+            <p:nvSpPr>
+              <p:cNvPr id="27" name="TextBox 26">
+                <a:extLst>
+                  <a:ext uri="{FF2B5EF4-FFF2-40B4-BE49-F238E27FC236}">
+                    <a16:creationId xmlns:a16="http://schemas.microsoft.com/office/drawing/2014/main" id="{F65D02AF-ECCF-618C-C7C3-834ACFAC9772}"/>
+                  </a:ext>
+                </a:extLst>
+              </p:cNvPr>
+              <p:cNvSpPr txBox="1"/>
+              <p:nvPr/>
+            </p:nvSpPr>
+            <p:spPr>
+              <a:xfrm>
+                <a:off x="7488216" y="4612321"/>
+                <a:ext cx="687958" cy="584775"/>
+              </a:xfrm>
+              <a:prstGeom prst="rect">
+                <a:avLst/>
+              </a:prstGeom>
+              <a:noFill/>
+            </p:spPr>
+            <p:txBody>
+              <a:bodyPr wrap="square">
+                <a:spAutoFit/>
+              </a:bodyPr>
+              <a:lstStyle/>
+              <a:p>
+                <a:pPr algn="ctr"/>
+                <a14:m>
+                  <m:oMathPara xmlns:m="http://schemas.openxmlformats.org/officeDocument/2006/math">
+                    <m:oMath>
+                      <m:r>
+                        <a:rPr lang="en-US" sz="3200" b="0" i="1" smtClean="0">
+                          <a:solidFill>
+                            <a:schemeClr val="tx1"/>
+                          </a:solidFill>
+                          <a:latin typeface="Cambria Math" panose="02040503050406030204" pitchFamily="18" charset="0"/>
+                          <a:ea typeface="Tahoma" panose="020B0604030504040204" pitchFamily="34" charset="0"/>
+                          <a:cs typeface="Tahoma" panose="020B0604030504040204" pitchFamily="34" charset="0"/>
+                        </a:rPr>
+                        <m:t>𝑥</m:t>
+                      </m:r>
+                    </m:oMath>
+                  </m:oMathPara>
+                </a14:m>
+                <a:endParaRPr lang="en-US" sz="3200" dirty="0">
+                  <a:solidFill>
+                    <a:schemeClr val="tx1"/>
+                  </a:solidFill>
+                  <a:latin typeface="Tahoma" panose="020B0604030504040204" pitchFamily="34" charset="0"/>
+                  <a:ea typeface="Tahoma" panose="020B0604030504040204" pitchFamily="34" charset="0"/>
+                  <a:cs typeface="Tahoma" panose="020B0604030504040204" pitchFamily="34" charset="0"/>
+                </a:endParaRPr>
+              </a:p>
+            </p:txBody>
+          </p:sp>
+        </mc:Choice>
+        <mc:Fallback>
+          <p:sp>
+            <p:nvSpPr>
+              <p:cNvPr id="27" name="TextBox 26">
+                <a:extLst>
+                  <a:ext uri="{FF2B5EF4-FFF2-40B4-BE49-F238E27FC236}">
+                    <a16:creationId xmlns:a16="http://schemas.microsoft.com/office/drawing/2014/main" id="{F65D02AF-ECCF-618C-C7C3-834ACFAC9772}"/>
+                  </a:ext>
+                </a:extLst>
+              </p:cNvPr>
+              <p:cNvSpPr txBox="1">
+                <a:spLocks noRot="1" noChangeAspect="1" noMove="1" noResize="1" noEditPoints="1" noAdjustHandles="1" noChangeArrowheads="1" noChangeShapeType="1" noTextEdit="1"/>
+              </p:cNvSpPr>
+              <p:nvPr/>
+            </p:nvSpPr>
+            <p:spPr>
+              <a:xfrm>
+                <a:off x="7488216" y="4612321"/>
+                <a:ext cx="687958" cy="584775"/>
+              </a:xfrm>
+              <a:prstGeom prst="rect">
+                <a:avLst/>
+              </a:prstGeom>
+              <a:blipFill>
+                <a:blip r:embed="rId6"/>
+                <a:stretch>
+                  <a:fillRect/>
+                </a:stretch>
+              </a:blipFill>
+            </p:spPr>
+            <p:txBody>
+              <a:bodyPr/>
+              <a:lstStyle/>
+              <a:p>
+                <a:r>
+                  <a:rPr lang="en-GB">
+                    <a:noFill/>
+                  </a:rPr>
+                  <a:t> </a:t>
+                </a:r>
+              </a:p>
+            </p:txBody>
+          </p:sp>
+        </mc:Fallback>
+      </mc:AlternateContent>
     </p:spTree>
     <p:extLst>
       <p:ext uri="{BB962C8B-B14F-4D97-AF65-F5344CB8AC3E}">
-        <p14:creationId xmlns:p14="http://schemas.microsoft.com/office/powerpoint/2010/main" val="2699379521"/>
+        <p14:creationId xmlns:p14="http://schemas.microsoft.com/office/powerpoint/2010/main" val="4071236100"/>
       </p:ext>
     </p:extLst>
   </p:cSld>

</xml_diff>

<commit_message>
Adjusted figure sizes, added newly fitted PES, edited poster draft
</commit_message>
<xml_diff>
--- a/HPO_figures.pptx
+++ b/HPO_figures.pptx
@@ -116,7 +116,7 @@
 <file path=ppt/revisionInfo.xml><?xml version="1.0" encoding="utf-8"?>
 <p1510:revInfo xmlns:a="http://schemas.openxmlformats.org/drawingml/2006/main" xmlns:r="http://schemas.openxmlformats.org/officeDocument/2006/relationships" xmlns:p1510="http://schemas.microsoft.com/office/powerpoint/2015/10/main">
   <p1510:revLst>
-    <p1510:client id="{80AB0109-F0B2-4F8E-80E6-FA50717ECDA8}" v="27" dt="2026-08-17T17:29:19.905"/>
+    <p1510:client id="{80AB0109-F0B2-4F8E-80E6-FA50717ECDA8}" v="28" dt="2026-08-19T14:51:01.506"/>
   </p1510:revLst>
 </p1510:revInfo>
 </file>
@@ -126,7 +126,7 @@
   <pc:docChgLst>
     <pc:chgData name="Ryan Mok" userId="2b5ff9b4bc27d924" providerId="LiveId" clId="{98BDB49B-93C9-4AB7-A5FC-395AE49E91C6}"/>
     <pc:docChg chg="undo custSel addSld modSld">
-      <pc:chgData name="Ryan Mok" userId="2b5ff9b4bc27d924" providerId="LiveId" clId="{98BDB49B-93C9-4AB7-A5FC-395AE49E91C6}" dt="2026-08-17T17:29:34.288" v="223" actId="1037"/>
+      <pc:chgData name="Ryan Mok" userId="2b5ff9b4bc27d924" providerId="LiveId" clId="{98BDB49B-93C9-4AB7-A5FC-395AE49E91C6}" dt="2026-08-19T14:51:01.506" v="224" actId="164"/>
       <pc:docMkLst>
         <pc:docMk/>
       </pc:docMkLst>
@@ -218,13 +218,13 @@
         </pc:cxnChg>
       </pc:sldChg>
       <pc:sldChg chg="addSp delSp modSp add mod">
-        <pc:chgData name="Ryan Mok" userId="2b5ff9b4bc27d924" providerId="LiveId" clId="{98BDB49B-93C9-4AB7-A5FC-395AE49E91C6}" dt="2026-08-17T17:29:34.288" v="223" actId="1037"/>
+        <pc:chgData name="Ryan Mok" userId="2b5ff9b4bc27d924" providerId="LiveId" clId="{98BDB49B-93C9-4AB7-A5FC-395AE49E91C6}" dt="2026-08-19T14:51:01.506" v="224" actId="164"/>
         <pc:sldMkLst>
           <pc:docMk/>
           <pc:sldMk cId="4071236100" sldId="257"/>
         </pc:sldMkLst>
         <pc:spChg chg="add mod">
-          <ac:chgData name="Ryan Mok" userId="2b5ff9b4bc27d924" providerId="LiveId" clId="{98BDB49B-93C9-4AB7-A5FC-395AE49E91C6}" dt="2026-08-17T16:45:58.704" v="122" actId="404"/>
+          <ac:chgData name="Ryan Mok" userId="2b5ff9b4bc27d924" providerId="LiveId" clId="{98BDB49B-93C9-4AB7-A5FC-395AE49E91C6}" dt="2026-08-19T14:51:01.506" v="224" actId="164"/>
           <ac:spMkLst>
             <pc:docMk/>
             <pc:sldMk cId="4071236100" sldId="257"/>
@@ -232,7 +232,7 @@
           </ac:spMkLst>
         </pc:spChg>
         <pc:spChg chg="mod topLvl">
-          <ac:chgData name="Ryan Mok" userId="2b5ff9b4bc27d924" providerId="LiveId" clId="{98BDB49B-93C9-4AB7-A5FC-395AE49E91C6}" dt="2026-08-17T16:43:41.882" v="72" actId="1037"/>
+          <ac:chgData name="Ryan Mok" userId="2b5ff9b4bc27d924" providerId="LiveId" clId="{98BDB49B-93C9-4AB7-A5FC-395AE49E91C6}" dt="2026-08-19T14:51:01.506" v="224" actId="164"/>
           <ac:spMkLst>
             <pc:docMk/>
             <pc:sldMk cId="4071236100" sldId="257"/>
@@ -240,7 +240,7 @@
           </ac:spMkLst>
         </pc:spChg>
         <pc:spChg chg="add mod">
-          <ac:chgData name="Ryan Mok" userId="2b5ff9b4bc27d924" providerId="LiveId" clId="{98BDB49B-93C9-4AB7-A5FC-395AE49E91C6}" dt="2026-08-17T16:46:07.933" v="126" actId="20577"/>
+          <ac:chgData name="Ryan Mok" userId="2b5ff9b4bc27d924" providerId="LiveId" clId="{98BDB49B-93C9-4AB7-A5FC-395AE49E91C6}" dt="2026-08-19T14:51:01.506" v="224" actId="164"/>
           <ac:spMkLst>
             <pc:docMk/>
             <pc:sldMk cId="4071236100" sldId="257"/>
@@ -248,7 +248,7 @@
           </ac:spMkLst>
         </pc:spChg>
         <pc:spChg chg="add mod">
-          <ac:chgData name="Ryan Mok" userId="2b5ff9b4bc27d924" providerId="LiveId" clId="{98BDB49B-93C9-4AB7-A5FC-395AE49E91C6}" dt="2026-08-17T16:46:22.963" v="140" actId="1076"/>
+          <ac:chgData name="Ryan Mok" userId="2b5ff9b4bc27d924" providerId="LiveId" clId="{98BDB49B-93C9-4AB7-A5FC-395AE49E91C6}" dt="2026-08-19T14:51:01.506" v="224" actId="164"/>
           <ac:spMkLst>
             <pc:docMk/>
             <pc:sldMk cId="4071236100" sldId="257"/>
@@ -256,7 +256,7 @@
           </ac:spMkLst>
         </pc:spChg>
         <pc:spChg chg="mod topLvl">
-          <ac:chgData name="Ryan Mok" userId="2b5ff9b4bc27d924" providerId="LiveId" clId="{98BDB49B-93C9-4AB7-A5FC-395AE49E91C6}" dt="2026-08-17T16:43:55.938" v="73" actId="1076"/>
+          <ac:chgData name="Ryan Mok" userId="2b5ff9b4bc27d924" providerId="LiveId" clId="{98BDB49B-93C9-4AB7-A5FC-395AE49E91C6}" dt="2026-08-19T14:51:01.506" v="224" actId="164"/>
           <ac:spMkLst>
             <pc:docMk/>
             <pc:sldMk cId="4071236100" sldId="257"/>
@@ -264,7 +264,7 @@
           </ac:spMkLst>
         </pc:spChg>
         <pc:spChg chg="mod topLvl">
-          <ac:chgData name="Ryan Mok" userId="2b5ff9b4bc27d924" providerId="LiveId" clId="{98BDB49B-93C9-4AB7-A5FC-395AE49E91C6}" dt="2026-08-17T16:43:41.882" v="72" actId="1037"/>
+          <ac:chgData name="Ryan Mok" userId="2b5ff9b4bc27d924" providerId="LiveId" clId="{98BDB49B-93C9-4AB7-A5FC-395AE49E91C6}" dt="2026-08-19T14:51:01.506" v="224" actId="164"/>
           <ac:spMkLst>
             <pc:docMk/>
             <pc:sldMk cId="4071236100" sldId="257"/>
@@ -272,7 +272,7 @@
           </ac:spMkLst>
         </pc:spChg>
         <pc:spChg chg="add mod">
-          <ac:chgData name="Ryan Mok" userId="2b5ff9b4bc27d924" providerId="LiveId" clId="{98BDB49B-93C9-4AB7-A5FC-395AE49E91C6}" dt="2026-08-17T17:29:34.288" v="223" actId="1037"/>
+          <ac:chgData name="Ryan Mok" userId="2b5ff9b4bc27d924" providerId="LiveId" clId="{98BDB49B-93C9-4AB7-A5FC-395AE49E91C6}" dt="2026-08-19T14:51:01.506" v="224" actId="164"/>
           <ac:spMkLst>
             <pc:docMk/>
             <pc:sldMk cId="4071236100" sldId="257"/>
@@ -280,51 +280,27 @@
           </ac:spMkLst>
         </pc:spChg>
         <pc:spChg chg="add mod">
-          <ac:chgData name="Ryan Mok" userId="2b5ff9b4bc27d924" providerId="LiveId" clId="{98BDB49B-93C9-4AB7-A5FC-395AE49E91C6}" dt="2026-08-17T17:29:34.288" v="223" actId="1037"/>
+          <ac:chgData name="Ryan Mok" userId="2b5ff9b4bc27d924" providerId="LiveId" clId="{98BDB49B-93C9-4AB7-A5FC-395AE49E91C6}" dt="2026-08-19T14:51:01.506" v="224" actId="164"/>
           <ac:spMkLst>
             <pc:docMk/>
             <pc:sldMk cId="4071236100" sldId="257"/>
             <ac:spMk id="27" creationId="{F65D02AF-ECCF-618C-C7C3-834ACFAC9772}"/>
           </ac:spMkLst>
         </pc:spChg>
-        <pc:spChg chg="del mod topLvl">
-          <ac:chgData name="Ryan Mok" userId="2b5ff9b4bc27d924" providerId="LiveId" clId="{98BDB49B-93C9-4AB7-A5FC-395AE49E91C6}" dt="2026-08-17T16:42:42.031" v="30" actId="478"/>
-          <ac:spMkLst>
-            <pc:docMk/>
-            <pc:sldMk cId="4071236100" sldId="257"/>
-            <ac:spMk id="44" creationId="{48668747-0EF8-6CDB-4521-9DE0F6D2B67E}"/>
-          </ac:spMkLst>
-        </pc:spChg>
-        <pc:spChg chg="del mod topLvl">
-          <ac:chgData name="Ryan Mok" userId="2b5ff9b4bc27d924" providerId="LiveId" clId="{98BDB49B-93C9-4AB7-A5FC-395AE49E91C6}" dt="2026-08-17T16:42:38.952" v="28" actId="478"/>
-          <ac:spMkLst>
-            <pc:docMk/>
-            <pc:sldMk cId="4071236100" sldId="257"/>
-            <ac:spMk id="46" creationId="{60EB6855-D5BF-1178-281A-C5DD44242AE4}"/>
-          </ac:spMkLst>
-        </pc:spChg>
         <pc:spChg chg="mod topLvl">
-          <ac:chgData name="Ryan Mok" userId="2b5ff9b4bc27d924" providerId="LiveId" clId="{98BDB49B-93C9-4AB7-A5FC-395AE49E91C6}" dt="2026-08-17T16:44:47.990" v="110" actId="1035"/>
+          <ac:chgData name="Ryan Mok" userId="2b5ff9b4bc27d924" providerId="LiveId" clId="{98BDB49B-93C9-4AB7-A5FC-395AE49E91C6}" dt="2026-08-19T14:51:01.506" v="224" actId="164"/>
           <ac:spMkLst>
             <pc:docMk/>
             <pc:sldMk cId="4071236100" sldId="257"/>
             <ac:spMk id="47" creationId="{E00A34CF-8AA1-2586-DF2E-3398498B3F66}"/>
           </ac:spMkLst>
         </pc:spChg>
-        <pc:spChg chg="del mod topLvl">
-          <ac:chgData name="Ryan Mok" userId="2b5ff9b4bc27d924" providerId="LiveId" clId="{98BDB49B-93C9-4AB7-A5FC-395AE49E91C6}" dt="2026-08-17T16:42:40.280" v="29" actId="478"/>
-          <ac:spMkLst>
-            <pc:docMk/>
-            <pc:sldMk cId="4071236100" sldId="257"/>
-            <ac:spMk id="49" creationId="{CC6421EA-F318-63B8-8604-FBD39F64576B}"/>
-          </ac:spMkLst>
-        </pc:spChg>
-        <pc:grpChg chg="del">
-          <ac:chgData name="Ryan Mok" userId="2b5ff9b4bc27d924" providerId="LiveId" clId="{98BDB49B-93C9-4AB7-A5FC-395AE49E91C6}" dt="2026-08-17T16:42:36.987" v="27" actId="165"/>
+        <pc:grpChg chg="add mod">
+          <ac:chgData name="Ryan Mok" userId="2b5ff9b4bc27d924" providerId="LiveId" clId="{98BDB49B-93C9-4AB7-A5FC-395AE49E91C6}" dt="2026-08-19T14:51:01.506" v="224" actId="164"/>
           <ac:grpSpMkLst>
             <pc:docMk/>
             <pc:sldMk cId="4071236100" sldId="257"/>
-            <ac:grpSpMk id="2" creationId="{A9649E30-066A-D4F8-C8F4-A0E0FE3C1924}"/>
+            <ac:grpSpMk id="2" creationId="{B3D7BB48-F011-6BD8-6C0C-0D6A07F955CF}"/>
           </ac:grpSpMkLst>
         </pc:grpChg>
         <pc:grpChg chg="add mod">
@@ -522,7 +498,7 @@
           <a:p>
             <a:fld id="{B9F7AD3A-2E00-40AC-B4EF-D2178F39DCFF}" type="datetimeFigureOut">
               <a:rPr lang="en-GB" smtClean="0"/>
-              <a:t>17/08/2026</a:t>
+              <a:t>19/08/2026</a:t>
             </a:fld>
             <a:endParaRPr lang="en-GB"/>
           </a:p>
@@ -722,7 +698,7 @@
           <a:p>
             <a:fld id="{B9F7AD3A-2E00-40AC-B4EF-D2178F39DCFF}" type="datetimeFigureOut">
               <a:rPr lang="en-GB" smtClean="0"/>
-              <a:t>17/08/2026</a:t>
+              <a:t>19/08/2026</a:t>
             </a:fld>
             <a:endParaRPr lang="en-GB"/>
           </a:p>
@@ -932,7 +908,7 @@
           <a:p>
             <a:fld id="{B9F7AD3A-2E00-40AC-B4EF-D2178F39DCFF}" type="datetimeFigureOut">
               <a:rPr lang="en-GB" smtClean="0"/>
-              <a:t>17/08/2026</a:t>
+              <a:t>19/08/2026</a:t>
             </a:fld>
             <a:endParaRPr lang="en-GB"/>
           </a:p>
@@ -1132,7 +1108,7 @@
           <a:p>
             <a:fld id="{B9F7AD3A-2E00-40AC-B4EF-D2178F39DCFF}" type="datetimeFigureOut">
               <a:rPr lang="en-GB" smtClean="0"/>
-              <a:t>17/08/2026</a:t>
+              <a:t>19/08/2026</a:t>
             </a:fld>
             <a:endParaRPr lang="en-GB"/>
           </a:p>
@@ -1408,7 +1384,7 @@
           <a:p>
             <a:fld id="{B9F7AD3A-2E00-40AC-B4EF-D2178F39DCFF}" type="datetimeFigureOut">
               <a:rPr lang="en-GB" smtClean="0"/>
-              <a:t>17/08/2026</a:t>
+              <a:t>19/08/2026</a:t>
             </a:fld>
             <a:endParaRPr lang="en-GB"/>
           </a:p>
@@ -1676,7 +1652,7 @@
           <a:p>
             <a:fld id="{B9F7AD3A-2E00-40AC-B4EF-D2178F39DCFF}" type="datetimeFigureOut">
               <a:rPr lang="en-GB" smtClean="0"/>
-              <a:t>17/08/2026</a:t>
+              <a:t>19/08/2026</a:t>
             </a:fld>
             <a:endParaRPr lang="en-GB"/>
           </a:p>
@@ -2091,7 +2067,7 @@
           <a:p>
             <a:fld id="{B9F7AD3A-2E00-40AC-B4EF-D2178F39DCFF}" type="datetimeFigureOut">
               <a:rPr lang="en-GB" smtClean="0"/>
-              <a:t>17/08/2026</a:t>
+              <a:t>19/08/2026</a:t>
             </a:fld>
             <a:endParaRPr lang="en-GB"/>
           </a:p>
@@ -2233,7 +2209,7 @@
           <a:p>
             <a:fld id="{B9F7AD3A-2E00-40AC-B4EF-D2178F39DCFF}" type="datetimeFigureOut">
               <a:rPr lang="en-GB" smtClean="0"/>
-              <a:t>17/08/2026</a:t>
+              <a:t>19/08/2026</a:t>
             </a:fld>
             <a:endParaRPr lang="en-GB"/>
           </a:p>
@@ -2346,7 +2322,7 @@
           <a:p>
             <a:fld id="{B9F7AD3A-2E00-40AC-B4EF-D2178F39DCFF}" type="datetimeFigureOut">
               <a:rPr lang="en-GB" smtClean="0"/>
-              <a:t>17/08/2026</a:t>
+              <a:t>19/08/2026</a:t>
             </a:fld>
             <a:endParaRPr lang="en-GB"/>
           </a:p>
@@ -2659,7 +2635,7 @@
           <a:p>
             <a:fld id="{B9F7AD3A-2E00-40AC-B4EF-D2178F39DCFF}" type="datetimeFigureOut">
               <a:rPr lang="en-GB" smtClean="0"/>
-              <a:t>17/08/2026</a:t>
+              <a:t>19/08/2026</a:t>
             </a:fld>
             <a:endParaRPr lang="en-GB"/>
           </a:p>
@@ -2948,7 +2924,7 @@
           <a:p>
             <a:fld id="{B9F7AD3A-2E00-40AC-B4EF-D2178F39DCFF}" type="datetimeFigureOut">
               <a:rPr lang="en-GB" smtClean="0"/>
-              <a:t>17/08/2026</a:t>
+              <a:t>19/08/2026</a:t>
             </a:fld>
             <a:endParaRPr lang="en-GB"/>
           </a:p>
@@ -3191,7 +3167,7 @@
           <a:p>
             <a:fld id="{B9F7AD3A-2E00-40AC-B4EF-D2178F39DCFF}" type="datetimeFigureOut">
               <a:rPr lang="en-GB" smtClean="0"/>
-              <a:t>17/08/2026</a:t>
+              <a:t>19/08/2026</a:t>
             </a:fld>
             <a:endParaRPr lang="en-GB"/>
           </a:p>
@@ -4309,657 +4285,12 @@
           <a:chExt cx="0" cy="0"/>
         </a:xfrm>
       </p:grpSpPr>
-      <p:sp>
-        <p:nvSpPr>
-          <p:cNvPr id="47" name="Arc 46">
-            <a:extLst>
-              <a:ext uri="{FF2B5EF4-FFF2-40B4-BE49-F238E27FC236}">
-                <a16:creationId xmlns:a16="http://schemas.microsoft.com/office/drawing/2014/main" id="{E00A34CF-8AA1-2586-DF2E-3398498B3F66}"/>
-              </a:ext>
-            </a:extLst>
-          </p:cNvPr>
-          <p:cNvSpPr/>
-          <p:nvPr/>
-        </p:nvSpPr>
-        <p:spPr>
-          <a:xfrm rot="5144585">
-            <a:off x="3582434" y="1481558"/>
-            <a:ext cx="2457356" cy="2423472"/>
-          </a:xfrm>
-          <a:prstGeom prst="arc">
-            <a:avLst>
-              <a:gd name="adj1" fmla="val 15496379"/>
-              <a:gd name="adj2" fmla="val 21546438"/>
-            </a:avLst>
-          </a:prstGeom>
-          <a:ln w="38100">
-            <a:solidFill>
-              <a:srgbClr val="FF0000"/>
-            </a:solidFill>
-          </a:ln>
-        </p:spPr>
-        <p:style>
-          <a:lnRef idx="2">
-            <a:schemeClr val="accent1"/>
-          </a:lnRef>
-          <a:fillRef idx="0">
-            <a:schemeClr val="accent1"/>
-          </a:fillRef>
-          <a:effectRef idx="1">
-            <a:schemeClr val="accent1"/>
-          </a:effectRef>
-          <a:fontRef idx="minor">
-            <a:schemeClr val="tx1"/>
-          </a:fontRef>
-        </p:style>
-        <p:txBody>
-          <a:bodyPr rtlCol="0" anchor="ctr"/>
-          <a:lstStyle/>
-          <a:p>
-            <a:pPr algn="ctr"/>
-            <a:endParaRPr lang="en-GB" dirty="0"/>
-          </a:p>
-        </p:txBody>
-      </p:sp>
-      <p:cxnSp>
-        <p:nvCxnSpPr>
-          <p:cNvPr id="11" name="Straight Connector 10">
-            <a:extLst>
-              <a:ext uri="{FF2B5EF4-FFF2-40B4-BE49-F238E27FC236}">
-                <a16:creationId xmlns:a16="http://schemas.microsoft.com/office/drawing/2014/main" id="{D53ADA0E-5BF2-20F8-24B9-306BCEC2A521}"/>
-              </a:ext>
-            </a:extLst>
-          </p:cNvPr>
-          <p:cNvCxnSpPr>
-            <a:cxnSpLocks/>
-          </p:cNvCxnSpPr>
-          <p:nvPr/>
-        </p:nvCxnSpPr>
-        <p:spPr>
-          <a:xfrm flipV="1">
-            <a:off x="4937969" y="1686675"/>
-            <a:ext cx="3099643" cy="1010479"/>
-          </a:xfrm>
-          <a:prstGeom prst="line">
-            <a:avLst/>
-          </a:prstGeom>
-          <a:ln w="38100"/>
-        </p:spPr>
-        <p:style>
-          <a:lnRef idx="2">
-            <a:schemeClr val="dk1"/>
-          </a:lnRef>
-          <a:fillRef idx="0">
-            <a:schemeClr val="dk1"/>
-          </a:fillRef>
-          <a:effectRef idx="1">
-            <a:schemeClr val="dk1"/>
-          </a:effectRef>
-          <a:fontRef idx="minor">
-            <a:schemeClr val="tx1"/>
-          </a:fontRef>
-        </p:style>
-      </p:cxnSp>
-      <p:sp>
-        <p:nvSpPr>
-          <p:cNvPr id="22" name="Oval 21">
-            <a:extLst>
-              <a:ext uri="{FF2B5EF4-FFF2-40B4-BE49-F238E27FC236}">
-                <a16:creationId xmlns:a16="http://schemas.microsoft.com/office/drawing/2014/main" id="{15F66337-BA7C-C813-B682-C1B81815E3D1}"/>
-              </a:ext>
-            </a:extLst>
-          </p:cNvPr>
-          <p:cNvSpPr/>
-          <p:nvPr/>
-        </p:nvSpPr>
-        <p:spPr>
-          <a:xfrm>
-            <a:off x="7297596" y="899191"/>
-            <a:ext cx="1480033" cy="1574968"/>
-          </a:xfrm>
-          <a:prstGeom prst="ellipse">
-            <a:avLst/>
-          </a:prstGeom>
-          <a:solidFill>
-            <a:srgbClr val="F2F2F2"/>
-          </a:solidFill>
-          <a:ln>
-            <a:solidFill>
-              <a:schemeClr val="tx1"/>
-            </a:solidFill>
-          </a:ln>
-        </p:spPr>
-        <p:style>
-          <a:lnRef idx="2">
-            <a:schemeClr val="accent1">
-              <a:shade val="15000"/>
-            </a:schemeClr>
-          </a:lnRef>
-          <a:fillRef idx="1">
-            <a:schemeClr val="accent1"/>
-          </a:fillRef>
-          <a:effectRef idx="0">
-            <a:schemeClr val="accent1"/>
-          </a:effectRef>
-          <a:fontRef idx="minor">
-            <a:schemeClr val="lt1"/>
-          </a:fontRef>
-        </p:style>
-        <p:txBody>
-          <a:bodyPr rtlCol="0" anchor="ctr"/>
-          <a:lstStyle/>
-          <a:p>
-            <a:pPr algn="ctr"/>
-            <a:r>
-              <a:rPr lang="en-US" sz="3600" dirty="0">
-                <a:solidFill>
-                  <a:schemeClr val="tx1"/>
-                </a:solidFill>
-                <a:latin typeface="Tahoma" panose="020B0604030504040204" pitchFamily="34" charset="0"/>
-                <a:ea typeface="Tahoma" panose="020B0604030504040204" pitchFamily="34" charset="0"/>
-                <a:cs typeface="Tahoma" panose="020B0604030504040204" pitchFamily="34" charset="0"/>
-              </a:rPr>
-              <a:t>H</a:t>
-            </a:r>
-          </a:p>
-        </p:txBody>
-      </p:sp>
-      <p:cxnSp>
-        <p:nvCxnSpPr>
-          <p:cNvPr id="23" name="Straight Connector 22">
-            <a:extLst>
-              <a:ext uri="{FF2B5EF4-FFF2-40B4-BE49-F238E27FC236}">
-                <a16:creationId xmlns:a16="http://schemas.microsoft.com/office/drawing/2014/main" id="{0F295CC0-DBF8-EFC2-9AF0-828D01A890F9}"/>
-              </a:ext>
-            </a:extLst>
-          </p:cNvPr>
-          <p:cNvCxnSpPr>
-            <a:cxnSpLocks/>
-          </p:cNvCxnSpPr>
-          <p:nvPr/>
-        </p:nvCxnSpPr>
-        <p:spPr>
-          <a:xfrm flipH="1" flipV="1">
-            <a:off x="4931455" y="2697154"/>
-            <a:ext cx="6514" cy="2926406"/>
-          </a:xfrm>
-          <a:prstGeom prst="line">
-            <a:avLst/>
-          </a:prstGeom>
-          <a:ln w="38100"/>
-        </p:spPr>
-        <p:style>
-          <a:lnRef idx="2">
-            <a:schemeClr val="dk1"/>
-          </a:lnRef>
-          <a:fillRef idx="0">
-            <a:schemeClr val="dk1"/>
-          </a:fillRef>
-          <a:effectRef idx="1">
-            <a:schemeClr val="dk1"/>
-          </a:effectRef>
-          <a:fontRef idx="minor">
-            <a:schemeClr val="tx1"/>
-          </a:fontRef>
-        </p:style>
-      </p:cxnSp>
-      <p:sp>
-        <p:nvSpPr>
-          <p:cNvPr id="24" name="Oval 23">
-            <a:extLst>
-              <a:ext uri="{FF2B5EF4-FFF2-40B4-BE49-F238E27FC236}">
-                <a16:creationId xmlns:a16="http://schemas.microsoft.com/office/drawing/2014/main" id="{280447AB-28FE-B511-8F76-F72F2704CC20}"/>
-              </a:ext>
-            </a:extLst>
-          </p:cNvPr>
-          <p:cNvSpPr/>
-          <p:nvPr/>
-        </p:nvSpPr>
-        <p:spPr>
-          <a:xfrm>
-            <a:off x="4191440" y="1909671"/>
-            <a:ext cx="1480033" cy="1574968"/>
-          </a:xfrm>
-          <a:prstGeom prst="ellipse">
-            <a:avLst/>
-          </a:prstGeom>
-          <a:solidFill>
-            <a:srgbClr val="8826C5"/>
-          </a:solidFill>
-        </p:spPr>
-        <p:style>
-          <a:lnRef idx="2">
-            <a:schemeClr val="accent1">
-              <a:shade val="15000"/>
-            </a:schemeClr>
-          </a:lnRef>
-          <a:fillRef idx="1">
-            <a:schemeClr val="accent1"/>
-          </a:fillRef>
-          <a:effectRef idx="0">
-            <a:schemeClr val="accent1"/>
-          </a:effectRef>
-          <a:fontRef idx="minor">
-            <a:schemeClr val="lt1"/>
-          </a:fontRef>
-        </p:style>
-        <p:txBody>
-          <a:bodyPr rtlCol="0" anchor="ctr"/>
-          <a:lstStyle/>
-          <a:p>
-            <a:pPr algn="ctr"/>
-            <a:r>
-              <a:rPr lang="en-US" sz="3600" dirty="0">
-                <a:solidFill>
-                  <a:schemeClr val="tx1"/>
-                </a:solidFill>
-                <a:latin typeface="Tahoma" panose="020B0604030504040204" pitchFamily="34" charset="0"/>
-                <a:ea typeface="Tahoma" panose="020B0604030504040204" pitchFamily="34" charset="0"/>
-                <a:cs typeface="Tahoma" panose="020B0604030504040204" pitchFamily="34" charset="0"/>
-              </a:rPr>
-              <a:t>P</a:t>
-            </a:r>
-          </a:p>
-        </p:txBody>
-      </p:sp>
-      <p:sp>
-        <p:nvSpPr>
-          <p:cNvPr id="10" name="Oval 9">
-            <a:extLst>
-              <a:ext uri="{FF2B5EF4-FFF2-40B4-BE49-F238E27FC236}">
-                <a16:creationId xmlns:a16="http://schemas.microsoft.com/office/drawing/2014/main" id="{38EF4465-53E9-89D7-ECDB-5EF19EE4809D}"/>
-              </a:ext>
-            </a:extLst>
-          </p:cNvPr>
-          <p:cNvSpPr/>
-          <p:nvPr/>
-        </p:nvSpPr>
-        <p:spPr>
-          <a:xfrm>
-            <a:off x="4191439" y="4751015"/>
-            <a:ext cx="1480033" cy="1574968"/>
-          </a:xfrm>
-          <a:prstGeom prst="ellipse">
-            <a:avLst/>
-          </a:prstGeom>
-          <a:solidFill>
-            <a:srgbClr val="D93528"/>
-          </a:solidFill>
-        </p:spPr>
-        <p:style>
-          <a:lnRef idx="2">
-            <a:schemeClr val="accent1">
-              <a:shade val="15000"/>
-            </a:schemeClr>
-          </a:lnRef>
-          <a:fillRef idx="1">
-            <a:schemeClr val="accent1"/>
-          </a:fillRef>
-          <a:effectRef idx="0">
-            <a:schemeClr val="accent1"/>
-          </a:effectRef>
-          <a:fontRef idx="minor">
-            <a:schemeClr val="lt1"/>
-          </a:fontRef>
-        </p:style>
-        <p:txBody>
-          <a:bodyPr rtlCol="0" anchor="ctr"/>
-          <a:lstStyle/>
-          <a:p>
-            <a:pPr algn="ctr"/>
-            <a:r>
-              <a:rPr lang="en-US" sz="3600" dirty="0">
-                <a:solidFill>
-                  <a:schemeClr val="tx1"/>
-                </a:solidFill>
-                <a:latin typeface="Tahoma" panose="020B0604030504040204" pitchFamily="34" charset="0"/>
-                <a:ea typeface="Tahoma" panose="020B0604030504040204" pitchFamily="34" charset="0"/>
-                <a:cs typeface="Tahoma" panose="020B0604030504040204" pitchFamily="34" charset="0"/>
-              </a:rPr>
-              <a:t>O</a:t>
-            </a:r>
-          </a:p>
-        </p:txBody>
-      </p:sp>
-      <mc:AlternateContent xmlns:mc="http://schemas.openxmlformats.org/markup-compatibility/2006">
-        <mc:Choice xmlns:a14="http://schemas.microsoft.com/office/drawing/2010/main" Requires="a14">
-          <p:sp>
-            <p:nvSpPr>
-              <p:cNvPr id="9" name="TextBox 8">
-                <a:extLst>
-                  <a:ext uri="{FF2B5EF4-FFF2-40B4-BE49-F238E27FC236}">
-                    <a16:creationId xmlns:a16="http://schemas.microsoft.com/office/drawing/2014/main" id="{B0B6BFB7-7EFB-DDC3-6926-0EB97780D9CC}"/>
-                  </a:ext>
-                </a:extLst>
-              </p:cNvPr>
-              <p:cNvSpPr txBox="1"/>
-              <p:nvPr/>
-            </p:nvSpPr>
-            <p:spPr>
-              <a:xfrm>
-                <a:off x="3728498" y="3670814"/>
-                <a:ext cx="1703087" cy="584775"/>
-              </a:xfrm>
-              <a:prstGeom prst="rect">
-                <a:avLst/>
-              </a:prstGeom>
-              <a:noFill/>
-            </p:spPr>
-            <p:txBody>
-              <a:bodyPr wrap="square" rtlCol="0">
-                <a:spAutoFit/>
-              </a:bodyPr>
-              <a:lstStyle/>
-              <a:p>
-                <a:pPr/>
-                <a14:m>
-                  <m:oMathPara xmlns:m="http://schemas.openxmlformats.org/officeDocument/2006/math">
-                    <m:oMath>
-                      <m:sSub>
-                        <m:sSubPr>
-                          <m:ctrlPr>
-                            <a:rPr lang="en-US" sz="3200" b="0" i="1" smtClean="0">
-                              <a:latin typeface="Cambria Math" panose="02040503050406030204" pitchFamily="18" charset="0"/>
-                              <a:cs typeface="Times New Roman" panose="02020603050405020304" pitchFamily="18" charset="0"/>
-                            </a:rPr>
-                          </m:ctrlPr>
-                        </m:sSubPr>
-                        <m:e>
-                          <m:r>
-                            <a:rPr lang="en-US" sz="3200" b="0" i="1" smtClean="0">
-                              <a:latin typeface="Cambria Math" panose="02040503050406030204" pitchFamily="18" charset="0"/>
-                              <a:cs typeface="Times New Roman" panose="02020603050405020304" pitchFamily="18" charset="0"/>
-                            </a:rPr>
-                            <m:t>𝑟</m:t>
-                          </m:r>
-                        </m:e>
-                        <m:sub>
-                          <m:r>
-                            <a:rPr lang="en-US" sz="3200" b="0" i="1" smtClean="0">
-                              <a:latin typeface="Cambria Math" panose="02040503050406030204" pitchFamily="18" charset="0"/>
-                              <a:cs typeface="Times New Roman" panose="02020603050405020304" pitchFamily="18" charset="0"/>
-                            </a:rPr>
-                            <m:t>1</m:t>
-                          </m:r>
-                        </m:sub>
-                      </m:sSub>
-                    </m:oMath>
-                  </m:oMathPara>
-                </a14:m>
-                <a:endParaRPr lang="en-GB" sz="3200" dirty="0">
-                  <a:latin typeface="Times New Roman" panose="02020603050405020304" pitchFamily="18" charset="0"/>
-                  <a:cs typeface="Times New Roman" panose="02020603050405020304" pitchFamily="18" charset="0"/>
-                </a:endParaRPr>
-              </a:p>
-            </p:txBody>
-          </p:sp>
-        </mc:Choice>
-        <mc:Fallback>
-          <p:sp>
-            <p:nvSpPr>
-              <p:cNvPr id="9" name="TextBox 8">
-                <a:extLst>
-                  <a:ext uri="{FF2B5EF4-FFF2-40B4-BE49-F238E27FC236}">
-                    <a16:creationId xmlns:a16="http://schemas.microsoft.com/office/drawing/2014/main" id="{B0B6BFB7-7EFB-DDC3-6926-0EB97780D9CC}"/>
-                  </a:ext>
-                </a:extLst>
-              </p:cNvPr>
-              <p:cNvSpPr txBox="1">
-                <a:spLocks noRot="1" noChangeAspect="1" noMove="1" noResize="1" noEditPoints="1" noAdjustHandles="1" noChangeArrowheads="1" noChangeShapeType="1" noTextEdit="1"/>
-              </p:cNvSpPr>
-              <p:nvPr/>
-            </p:nvSpPr>
-            <p:spPr>
-              <a:xfrm>
-                <a:off x="3728498" y="3670814"/>
-                <a:ext cx="1703087" cy="584775"/>
-              </a:xfrm>
-              <a:prstGeom prst="rect">
-                <a:avLst/>
-              </a:prstGeom>
-              <a:blipFill>
-                <a:blip r:embed="rId2"/>
-                <a:stretch>
-                  <a:fillRect/>
-                </a:stretch>
-              </a:blipFill>
-            </p:spPr>
-            <p:txBody>
-              <a:bodyPr/>
-              <a:lstStyle/>
-              <a:p>
-                <a:r>
-                  <a:rPr lang="en-GB">
-                    <a:noFill/>
-                  </a:rPr>
-                  <a:t> </a:t>
-                </a:r>
-              </a:p>
-            </p:txBody>
-          </p:sp>
-        </mc:Fallback>
-      </mc:AlternateContent>
-      <mc:AlternateContent xmlns:mc="http://schemas.openxmlformats.org/markup-compatibility/2006">
-        <mc:Choice xmlns:a14="http://schemas.microsoft.com/office/drawing/2010/main" Requires="a14">
-          <p:sp>
-            <p:nvSpPr>
-              <p:cNvPr id="13" name="TextBox 12">
-                <a:extLst>
-                  <a:ext uri="{FF2B5EF4-FFF2-40B4-BE49-F238E27FC236}">
-                    <a16:creationId xmlns:a16="http://schemas.microsoft.com/office/drawing/2014/main" id="{FD075C99-06C4-26D6-83AD-AD6C788886EF}"/>
-                  </a:ext>
-                </a:extLst>
-              </p:cNvPr>
-              <p:cNvSpPr txBox="1"/>
-              <p:nvPr/>
-            </p:nvSpPr>
-            <p:spPr>
-              <a:xfrm>
-                <a:off x="5449922" y="1500500"/>
-                <a:ext cx="1703087" cy="584775"/>
-              </a:xfrm>
-              <a:prstGeom prst="rect">
-                <a:avLst/>
-              </a:prstGeom>
-              <a:noFill/>
-            </p:spPr>
-            <p:txBody>
-              <a:bodyPr wrap="square" rtlCol="0">
-                <a:spAutoFit/>
-              </a:bodyPr>
-              <a:lstStyle/>
-              <a:p>
-                <a:pPr/>
-                <a14:m>
-                  <m:oMathPara xmlns:m="http://schemas.openxmlformats.org/officeDocument/2006/math">
-                    <m:oMath>
-                      <m:sSub>
-                        <m:sSubPr>
-                          <m:ctrlPr>
-                            <a:rPr lang="en-US" sz="3200" b="0" i="1" smtClean="0">
-                              <a:latin typeface="Cambria Math" panose="02040503050406030204" pitchFamily="18" charset="0"/>
-                              <a:cs typeface="Times New Roman" panose="02020603050405020304" pitchFamily="18" charset="0"/>
-                            </a:rPr>
-                          </m:ctrlPr>
-                        </m:sSubPr>
-                        <m:e>
-                          <m:r>
-                            <a:rPr lang="en-US" sz="3200" b="0" i="1" smtClean="0">
-                              <a:latin typeface="Cambria Math" panose="02040503050406030204" pitchFamily="18" charset="0"/>
-                              <a:cs typeface="Times New Roman" panose="02020603050405020304" pitchFamily="18" charset="0"/>
-                            </a:rPr>
-                            <m:t>𝑟</m:t>
-                          </m:r>
-                        </m:e>
-                        <m:sub>
-                          <m:r>
-                            <a:rPr lang="en-US" sz="3200" b="0" i="1" smtClean="0">
-                              <a:latin typeface="Cambria Math" panose="02040503050406030204" pitchFamily="18" charset="0"/>
-                              <a:cs typeface="Times New Roman" panose="02020603050405020304" pitchFamily="18" charset="0"/>
-                            </a:rPr>
-                            <m:t>2</m:t>
-                          </m:r>
-                        </m:sub>
-                      </m:sSub>
-                    </m:oMath>
-                  </m:oMathPara>
-                </a14:m>
-                <a:endParaRPr lang="en-GB" sz="3200" dirty="0">
-                  <a:latin typeface="Times New Roman" panose="02020603050405020304" pitchFamily="18" charset="0"/>
-                  <a:cs typeface="Times New Roman" panose="02020603050405020304" pitchFamily="18" charset="0"/>
-                </a:endParaRPr>
-              </a:p>
-            </p:txBody>
-          </p:sp>
-        </mc:Choice>
-        <mc:Fallback>
-          <p:sp>
-            <p:nvSpPr>
-              <p:cNvPr id="13" name="TextBox 12">
-                <a:extLst>
-                  <a:ext uri="{FF2B5EF4-FFF2-40B4-BE49-F238E27FC236}">
-                    <a16:creationId xmlns:a16="http://schemas.microsoft.com/office/drawing/2014/main" id="{FD075C99-06C4-26D6-83AD-AD6C788886EF}"/>
-                  </a:ext>
-                </a:extLst>
-              </p:cNvPr>
-              <p:cNvSpPr txBox="1">
-                <a:spLocks noRot="1" noChangeAspect="1" noMove="1" noResize="1" noEditPoints="1" noAdjustHandles="1" noChangeArrowheads="1" noChangeShapeType="1" noTextEdit="1"/>
-              </p:cNvSpPr>
-              <p:nvPr/>
-            </p:nvSpPr>
-            <p:spPr>
-              <a:xfrm>
-                <a:off x="5449922" y="1500500"/>
-                <a:ext cx="1703087" cy="584775"/>
-              </a:xfrm>
-              <a:prstGeom prst="rect">
-                <a:avLst/>
-              </a:prstGeom>
-              <a:blipFill>
-                <a:blip r:embed="rId3"/>
-                <a:stretch>
-                  <a:fillRect/>
-                </a:stretch>
-              </a:blipFill>
-            </p:spPr>
-            <p:txBody>
-              <a:bodyPr/>
-              <a:lstStyle/>
-              <a:p>
-                <a:r>
-                  <a:rPr lang="en-GB">
-                    <a:noFill/>
-                  </a:rPr>
-                  <a:t> </a:t>
-                </a:r>
-              </a:p>
-            </p:txBody>
-          </p:sp>
-        </mc:Fallback>
-      </mc:AlternateContent>
-      <mc:AlternateContent xmlns:mc="http://schemas.openxmlformats.org/markup-compatibility/2006">
-        <mc:Choice xmlns:a14="http://schemas.microsoft.com/office/drawing/2010/main" Requires="a14">
-          <p:sp>
-            <p:nvSpPr>
-              <p:cNvPr id="15" name="TextBox 14">
-                <a:extLst>
-                  <a:ext uri="{FF2B5EF4-FFF2-40B4-BE49-F238E27FC236}">
-                    <a16:creationId xmlns:a16="http://schemas.microsoft.com/office/drawing/2014/main" id="{D29B6249-D196-AC9D-C6B8-018AAD065877}"/>
-                  </a:ext>
-                </a:extLst>
-              </p:cNvPr>
-              <p:cNvSpPr txBox="1"/>
-              <p:nvPr/>
-            </p:nvSpPr>
-            <p:spPr>
-              <a:xfrm>
-                <a:off x="5186681" y="3192580"/>
-                <a:ext cx="1703087" cy="584775"/>
-              </a:xfrm>
-              <a:prstGeom prst="rect">
-                <a:avLst/>
-              </a:prstGeom>
-              <a:noFill/>
-            </p:spPr>
-            <p:txBody>
-              <a:bodyPr wrap="square" rtlCol="0">
-                <a:spAutoFit/>
-              </a:bodyPr>
-              <a:lstStyle/>
-              <a:p>
-                <a:pPr/>
-                <a14:m>
-                  <m:oMathPara xmlns:m="http://schemas.openxmlformats.org/officeDocument/2006/math">
-                    <m:oMath>
-                      <m:r>
-                        <a:rPr lang="en-US" sz="3200" b="0" i="1" smtClean="0">
-                          <a:latin typeface="Cambria Math" panose="02040503050406030204" pitchFamily="18" charset="0"/>
-                          <a:cs typeface="Times New Roman" panose="02020603050405020304" pitchFamily="18" charset="0"/>
-                        </a:rPr>
-                        <m:t>𝜃</m:t>
-                      </m:r>
-                    </m:oMath>
-                  </m:oMathPara>
-                </a14:m>
-                <a:endParaRPr lang="en-GB" sz="3200" dirty="0">
-                  <a:latin typeface="Times New Roman" panose="02020603050405020304" pitchFamily="18" charset="0"/>
-                  <a:cs typeface="Times New Roman" panose="02020603050405020304" pitchFamily="18" charset="0"/>
-                </a:endParaRPr>
-              </a:p>
-            </p:txBody>
-          </p:sp>
-        </mc:Choice>
-        <mc:Fallback>
-          <p:sp>
-            <p:nvSpPr>
-              <p:cNvPr id="15" name="TextBox 14">
-                <a:extLst>
-                  <a:ext uri="{FF2B5EF4-FFF2-40B4-BE49-F238E27FC236}">
-                    <a16:creationId xmlns:a16="http://schemas.microsoft.com/office/drawing/2014/main" id="{D29B6249-D196-AC9D-C6B8-018AAD065877}"/>
-                  </a:ext>
-                </a:extLst>
-              </p:cNvPr>
-              <p:cNvSpPr txBox="1">
-                <a:spLocks noRot="1" noChangeAspect="1" noMove="1" noResize="1" noEditPoints="1" noAdjustHandles="1" noChangeArrowheads="1" noChangeShapeType="1" noTextEdit="1"/>
-              </p:cNvSpPr>
-              <p:nvPr/>
-            </p:nvSpPr>
-            <p:spPr>
-              <a:xfrm>
-                <a:off x="5186681" y="3192580"/>
-                <a:ext cx="1703087" cy="584775"/>
-              </a:xfrm>
-              <a:prstGeom prst="rect">
-                <a:avLst/>
-              </a:prstGeom>
-              <a:blipFill>
-                <a:blip r:embed="rId4"/>
-                <a:stretch>
-                  <a:fillRect/>
-                </a:stretch>
-              </a:blipFill>
-            </p:spPr>
-            <p:txBody>
-              <a:bodyPr/>
-              <a:lstStyle/>
-              <a:p>
-                <a:r>
-                  <a:rPr lang="en-GB">
-                    <a:noFill/>
-                  </a:rPr>
-                  <a:t> </a:t>
-                </a:r>
-              </a:p>
-            </p:txBody>
-          </p:sp>
-        </mc:Fallback>
-      </mc:AlternateContent>
       <p:grpSp>
         <p:nvGrpSpPr>
-          <p:cNvPr id="20" name="Group 19">
-            <a:extLst>
-              <a:ext uri="{FF2B5EF4-FFF2-40B4-BE49-F238E27FC236}">
-                <a16:creationId xmlns:a16="http://schemas.microsoft.com/office/drawing/2014/main" id="{612D1359-D49E-F522-3580-95ACCFAD79ED}"/>
+          <p:cNvPr id="2" name="Group 1">
+            <a:extLst>
+              <a:ext uri="{FF2B5EF4-FFF2-40B4-BE49-F238E27FC236}">
+                <a16:creationId xmlns:a16="http://schemas.microsoft.com/office/drawing/2014/main" id="{B3D7BB48-F011-6BD8-6C0C-0D6A07F955CF}"/>
               </a:ext>
             </a:extLst>
           </p:cNvPr>
@@ -4968,18 +4299,70 @@
         </p:nvGrpSpPr>
         <p:grpSpPr>
           <a:xfrm>
-            <a:off x="6748363" y="3746943"/>
-            <a:ext cx="990759" cy="1022926"/>
-            <a:chOff x="6595459" y="3777355"/>
-            <a:chExt cx="990759" cy="1022926"/>
+            <a:off x="3599376" y="899191"/>
+            <a:ext cx="5178253" cy="5426792"/>
+            <a:chOff x="3599376" y="899191"/>
+            <a:chExt cx="5178253" cy="5426792"/>
           </a:xfrm>
         </p:grpSpPr>
+        <p:sp>
+          <p:nvSpPr>
+            <p:cNvPr id="47" name="Arc 46">
+              <a:extLst>
+                <a:ext uri="{FF2B5EF4-FFF2-40B4-BE49-F238E27FC236}">
+                  <a16:creationId xmlns:a16="http://schemas.microsoft.com/office/drawing/2014/main" id="{E00A34CF-8AA1-2586-DF2E-3398498B3F66}"/>
+                </a:ext>
+              </a:extLst>
+            </p:cNvPr>
+            <p:cNvSpPr/>
+            <p:nvPr/>
+          </p:nvSpPr>
+          <p:spPr>
+            <a:xfrm rot="5144585">
+              <a:off x="3582434" y="1481558"/>
+              <a:ext cx="2457356" cy="2423472"/>
+            </a:xfrm>
+            <a:prstGeom prst="arc">
+              <a:avLst>
+                <a:gd name="adj1" fmla="val 15496379"/>
+                <a:gd name="adj2" fmla="val 21546438"/>
+              </a:avLst>
+            </a:prstGeom>
+            <a:ln w="38100">
+              <a:solidFill>
+                <a:srgbClr val="FF0000"/>
+              </a:solidFill>
+            </a:ln>
+          </p:spPr>
+          <p:style>
+            <a:lnRef idx="2">
+              <a:schemeClr val="accent1"/>
+            </a:lnRef>
+            <a:fillRef idx="0">
+              <a:schemeClr val="accent1"/>
+            </a:fillRef>
+            <a:effectRef idx="1">
+              <a:schemeClr val="accent1"/>
+            </a:effectRef>
+            <a:fontRef idx="minor">
+              <a:schemeClr val="tx1"/>
+            </a:fontRef>
+          </p:style>
+          <p:txBody>
+            <a:bodyPr rtlCol="0" anchor="ctr"/>
+            <a:lstStyle/>
+            <a:p>
+              <a:pPr algn="ctr"/>
+              <a:endParaRPr lang="en-GB" dirty="0"/>
+            </a:p>
+          </p:txBody>
+        </p:sp>
         <p:cxnSp>
           <p:nvCxnSpPr>
-            <p:cNvPr id="16" name="Straight Connector 15">
+            <p:cNvPr id="11" name="Straight Connector 10">
               <a:extLst>
                 <a:ext uri="{FF2B5EF4-FFF2-40B4-BE49-F238E27FC236}">
-                  <a16:creationId xmlns:a16="http://schemas.microsoft.com/office/drawing/2014/main" id="{96AEE7BF-AE50-F70D-1016-7AC735D1419B}"/>
+                  <a16:creationId xmlns:a16="http://schemas.microsoft.com/office/drawing/2014/main" id="{D53ADA0E-5BF2-20F8-24B9-306BCEC2A521}"/>
                 </a:ext>
               </a:extLst>
             </p:cNvPr>
@@ -4989,16 +4372,14 @@
             <p:nvPr/>
           </p:nvCxnSpPr>
           <p:spPr>
-            <a:xfrm>
-              <a:off x="6601809" y="3777355"/>
-              <a:ext cx="0" cy="1022926"/>
+            <a:xfrm flipV="1">
+              <a:off x="4937969" y="1686675"/>
+              <a:ext cx="3099643" cy="1010479"/>
             </a:xfrm>
             <a:prstGeom prst="line">
               <a:avLst/>
             </a:prstGeom>
-            <a:ln w="28575">
-              <a:headEnd type="triangle"/>
-            </a:ln>
+            <a:ln w="38100"/>
           </p:spPr>
           <p:style>
             <a:lnRef idx="2">
@@ -5015,12 +4396,76 @@
             </a:fontRef>
           </p:style>
         </p:cxnSp>
+        <p:sp>
+          <p:nvSpPr>
+            <p:cNvPr id="22" name="Oval 21">
+              <a:extLst>
+                <a:ext uri="{FF2B5EF4-FFF2-40B4-BE49-F238E27FC236}">
+                  <a16:creationId xmlns:a16="http://schemas.microsoft.com/office/drawing/2014/main" id="{15F66337-BA7C-C813-B682-C1B81815E3D1}"/>
+                </a:ext>
+              </a:extLst>
+            </p:cNvPr>
+            <p:cNvSpPr/>
+            <p:nvPr/>
+          </p:nvSpPr>
+          <p:spPr>
+            <a:xfrm>
+              <a:off x="7297596" y="899191"/>
+              <a:ext cx="1480033" cy="1574968"/>
+            </a:xfrm>
+            <a:prstGeom prst="ellipse">
+              <a:avLst/>
+            </a:prstGeom>
+            <a:solidFill>
+              <a:srgbClr val="F2F2F2"/>
+            </a:solidFill>
+            <a:ln>
+              <a:solidFill>
+                <a:schemeClr val="tx1"/>
+              </a:solidFill>
+            </a:ln>
+          </p:spPr>
+          <p:style>
+            <a:lnRef idx="2">
+              <a:schemeClr val="accent1">
+                <a:shade val="15000"/>
+              </a:schemeClr>
+            </a:lnRef>
+            <a:fillRef idx="1">
+              <a:schemeClr val="accent1"/>
+            </a:fillRef>
+            <a:effectRef idx="0">
+              <a:schemeClr val="accent1"/>
+            </a:effectRef>
+            <a:fontRef idx="minor">
+              <a:schemeClr val="lt1"/>
+            </a:fontRef>
+          </p:style>
+          <p:txBody>
+            <a:bodyPr rtlCol="0" anchor="ctr"/>
+            <a:lstStyle/>
+            <a:p>
+              <a:pPr algn="ctr"/>
+              <a:r>
+                <a:rPr lang="en-US" sz="3600" dirty="0">
+                  <a:solidFill>
+                    <a:schemeClr val="tx1"/>
+                  </a:solidFill>
+                  <a:latin typeface="Tahoma" panose="020B0604030504040204" pitchFamily="34" charset="0"/>
+                  <a:ea typeface="Tahoma" panose="020B0604030504040204" pitchFamily="34" charset="0"/>
+                  <a:cs typeface="Tahoma" panose="020B0604030504040204" pitchFamily="34" charset="0"/>
+                </a:rPr>
+                <a:t>H</a:t>
+              </a:r>
+            </a:p>
+          </p:txBody>
+        </p:sp>
         <p:cxnSp>
           <p:nvCxnSpPr>
-            <p:cNvPr id="18" name="Straight Connector 17">
+            <p:cNvPr id="23" name="Straight Connector 22">
               <a:extLst>
                 <a:ext uri="{FF2B5EF4-FFF2-40B4-BE49-F238E27FC236}">
-                  <a16:creationId xmlns:a16="http://schemas.microsoft.com/office/drawing/2014/main" id="{E4F6C35F-EC06-C35D-DB8C-CC0A42733084}"/>
+                  <a16:creationId xmlns:a16="http://schemas.microsoft.com/office/drawing/2014/main" id="{0F295CC0-DBF8-EFC2-9AF0-828D01A890F9}"/>
                 </a:ext>
               </a:extLst>
             </p:cNvPr>
@@ -5030,16 +4475,14 @@
             <p:nvPr/>
           </p:nvCxnSpPr>
           <p:spPr>
-            <a:xfrm flipH="1">
-              <a:off x="6595459" y="4793931"/>
-              <a:ext cx="990759" cy="0"/>
+            <a:xfrm flipH="1" flipV="1">
+              <a:off x="4931455" y="2697154"/>
+              <a:ext cx="6514" cy="2926406"/>
             </a:xfrm>
             <a:prstGeom prst="line">
               <a:avLst/>
             </a:prstGeom>
-            <a:ln w="28575">
-              <a:headEnd type="triangle"/>
-            </a:ln>
+            <a:ln w="38100"/>
           </p:spPr>
           <p:style>
             <a:lnRef idx="2">
@@ -5056,217 +4499,771 @@
             </a:fontRef>
           </p:style>
         </p:cxnSp>
-      </p:grpSp>
-      <mc:AlternateContent xmlns:mc="http://schemas.openxmlformats.org/markup-compatibility/2006">
-        <mc:Choice xmlns:a14="http://schemas.microsoft.com/office/drawing/2010/main" Requires="a14">
-          <p:sp>
-            <p:nvSpPr>
-              <p:cNvPr id="25" name="TextBox 24">
-                <a:extLst>
-                  <a:ext uri="{FF2B5EF4-FFF2-40B4-BE49-F238E27FC236}">
-                    <a16:creationId xmlns:a16="http://schemas.microsoft.com/office/drawing/2014/main" id="{DCAE7460-EF02-940E-C124-B9FE596D4C3B}"/>
-                  </a:ext>
-                </a:extLst>
-              </p:cNvPr>
-              <p:cNvSpPr txBox="1"/>
-              <p:nvPr/>
-            </p:nvSpPr>
-            <p:spPr>
-              <a:xfrm>
-                <a:off x="6748139" y="3523948"/>
-                <a:ext cx="687958" cy="580344"/>
-              </a:xfrm>
-              <a:prstGeom prst="rect">
-                <a:avLst/>
-              </a:prstGeom>
-              <a:noFill/>
-            </p:spPr>
-            <p:txBody>
-              <a:bodyPr wrap="square">
-                <a:spAutoFit/>
-              </a:bodyPr>
-              <a:lstStyle/>
-              <a:p>
-                <a:pPr algn="ctr"/>
-                <a14:m>
-                  <m:oMathPara xmlns:m="http://schemas.openxmlformats.org/officeDocument/2006/math">
-                    <m:oMath>
-                      <m:r>
-                        <a:rPr lang="en-US" sz="2800" b="0" i="1" smtClean="0">
-                          <a:solidFill>
-                            <a:schemeClr val="tx1"/>
-                          </a:solidFill>
-                          <a:latin typeface="Cambria Math" panose="02040503050406030204" pitchFamily="18" charset="0"/>
-                          <a:ea typeface="Tahoma" panose="020B0604030504040204" pitchFamily="34" charset="0"/>
-                          <a:cs typeface="Tahoma" panose="020B0604030504040204" pitchFamily="34" charset="0"/>
-                        </a:rPr>
-                        <m:t>𝑧</m:t>
-                      </m:r>
-                    </m:oMath>
-                  </m:oMathPara>
-                </a14:m>
-                <a:endParaRPr lang="en-US" sz="3200" dirty="0">
+        <p:sp>
+          <p:nvSpPr>
+            <p:cNvPr id="24" name="Oval 23">
+              <a:extLst>
+                <a:ext uri="{FF2B5EF4-FFF2-40B4-BE49-F238E27FC236}">
+                  <a16:creationId xmlns:a16="http://schemas.microsoft.com/office/drawing/2014/main" id="{280447AB-28FE-B511-8F76-F72F2704CC20}"/>
+                </a:ext>
+              </a:extLst>
+            </p:cNvPr>
+            <p:cNvSpPr/>
+            <p:nvPr/>
+          </p:nvSpPr>
+          <p:spPr>
+            <a:xfrm>
+              <a:off x="4191440" y="1909671"/>
+              <a:ext cx="1480033" cy="1574968"/>
+            </a:xfrm>
+            <a:prstGeom prst="ellipse">
+              <a:avLst/>
+            </a:prstGeom>
+            <a:solidFill>
+              <a:srgbClr val="8826C5"/>
+            </a:solidFill>
+          </p:spPr>
+          <p:style>
+            <a:lnRef idx="2">
+              <a:schemeClr val="accent1">
+                <a:shade val="15000"/>
+              </a:schemeClr>
+            </a:lnRef>
+            <a:fillRef idx="1">
+              <a:schemeClr val="accent1"/>
+            </a:fillRef>
+            <a:effectRef idx="0">
+              <a:schemeClr val="accent1"/>
+            </a:effectRef>
+            <a:fontRef idx="minor">
+              <a:schemeClr val="lt1"/>
+            </a:fontRef>
+          </p:style>
+          <p:txBody>
+            <a:bodyPr rtlCol="0" anchor="ctr"/>
+            <a:lstStyle/>
+            <a:p>
+              <a:pPr algn="ctr"/>
+              <a:r>
+                <a:rPr lang="en-US" sz="3600" dirty="0">
                   <a:solidFill>
                     <a:schemeClr val="tx1"/>
                   </a:solidFill>
                   <a:latin typeface="Tahoma" panose="020B0604030504040204" pitchFamily="34" charset="0"/>
                   <a:ea typeface="Tahoma" panose="020B0604030504040204" pitchFamily="34" charset="0"/>
                   <a:cs typeface="Tahoma" panose="020B0604030504040204" pitchFamily="34" charset="0"/>
-                </a:endParaRPr>
-              </a:p>
-            </p:txBody>
-          </p:sp>
-        </mc:Choice>
-        <mc:Fallback>
-          <p:sp>
-            <p:nvSpPr>
-              <p:cNvPr id="25" name="TextBox 24">
-                <a:extLst>
-                  <a:ext uri="{FF2B5EF4-FFF2-40B4-BE49-F238E27FC236}">
-                    <a16:creationId xmlns:a16="http://schemas.microsoft.com/office/drawing/2014/main" id="{DCAE7460-EF02-940E-C124-B9FE596D4C3B}"/>
-                  </a:ext>
-                </a:extLst>
-              </p:cNvPr>
-              <p:cNvSpPr txBox="1">
-                <a:spLocks noRot="1" noChangeAspect="1" noMove="1" noResize="1" noEditPoints="1" noAdjustHandles="1" noChangeArrowheads="1" noChangeShapeType="1" noTextEdit="1"/>
-              </p:cNvSpPr>
-              <p:nvPr/>
-            </p:nvSpPr>
-            <p:spPr>
-              <a:xfrm>
-                <a:off x="6748139" y="3523948"/>
-                <a:ext cx="687958" cy="580344"/>
-              </a:xfrm>
-              <a:prstGeom prst="rect">
-                <a:avLst/>
-              </a:prstGeom>
-              <a:blipFill>
-                <a:blip r:embed="rId5"/>
-                <a:stretch>
-                  <a:fillRect/>
-                </a:stretch>
-              </a:blipFill>
-            </p:spPr>
-            <p:txBody>
-              <a:bodyPr/>
-              <a:lstStyle/>
-              <a:p>
-                <a:r>
-                  <a:rPr lang="en-GB">
-                    <a:noFill/>
-                  </a:rPr>
-                  <a:t> </a:t>
-                </a:r>
-              </a:p>
-            </p:txBody>
-          </p:sp>
-        </mc:Fallback>
-      </mc:AlternateContent>
-      <mc:AlternateContent xmlns:mc="http://schemas.openxmlformats.org/markup-compatibility/2006">
-        <mc:Choice xmlns:a14="http://schemas.microsoft.com/office/drawing/2010/main" Requires="a14">
-          <p:sp>
-            <p:nvSpPr>
-              <p:cNvPr id="27" name="TextBox 26">
-                <a:extLst>
-                  <a:ext uri="{FF2B5EF4-FFF2-40B4-BE49-F238E27FC236}">
-                    <a16:creationId xmlns:a16="http://schemas.microsoft.com/office/drawing/2014/main" id="{F65D02AF-ECCF-618C-C7C3-834ACFAC9772}"/>
-                  </a:ext>
-                </a:extLst>
-              </p:cNvPr>
-              <p:cNvSpPr txBox="1"/>
-              <p:nvPr/>
-            </p:nvSpPr>
-            <p:spPr>
-              <a:xfrm>
-                <a:off x="7488216" y="4612321"/>
-                <a:ext cx="687958" cy="584775"/>
-              </a:xfrm>
-              <a:prstGeom prst="rect">
-                <a:avLst/>
-              </a:prstGeom>
-              <a:noFill/>
-            </p:spPr>
-            <p:txBody>
-              <a:bodyPr wrap="square">
-                <a:spAutoFit/>
-              </a:bodyPr>
-              <a:lstStyle/>
-              <a:p>
-                <a:pPr algn="ctr"/>
-                <a14:m>
-                  <m:oMathPara xmlns:m="http://schemas.openxmlformats.org/officeDocument/2006/math">
-                    <m:oMath>
-                      <m:r>
-                        <a:rPr lang="en-US" sz="3200" b="0" i="1" smtClean="0">
-                          <a:solidFill>
-                            <a:schemeClr val="tx1"/>
-                          </a:solidFill>
-                          <a:latin typeface="Cambria Math" panose="02040503050406030204" pitchFamily="18" charset="0"/>
-                          <a:ea typeface="Tahoma" panose="020B0604030504040204" pitchFamily="34" charset="0"/>
-                          <a:cs typeface="Tahoma" panose="020B0604030504040204" pitchFamily="34" charset="0"/>
-                        </a:rPr>
-                        <m:t>𝑥</m:t>
-                      </m:r>
-                    </m:oMath>
-                  </m:oMathPara>
-                </a14:m>
-                <a:endParaRPr lang="en-US" sz="3200" dirty="0">
+                </a:rPr>
+                <a:t>P</a:t>
+              </a:r>
+            </a:p>
+          </p:txBody>
+        </p:sp>
+        <p:sp>
+          <p:nvSpPr>
+            <p:cNvPr id="10" name="Oval 9">
+              <a:extLst>
+                <a:ext uri="{FF2B5EF4-FFF2-40B4-BE49-F238E27FC236}">
+                  <a16:creationId xmlns:a16="http://schemas.microsoft.com/office/drawing/2014/main" id="{38EF4465-53E9-89D7-ECDB-5EF19EE4809D}"/>
+                </a:ext>
+              </a:extLst>
+            </p:cNvPr>
+            <p:cNvSpPr/>
+            <p:nvPr/>
+          </p:nvSpPr>
+          <p:spPr>
+            <a:xfrm>
+              <a:off x="4191439" y="4751015"/>
+              <a:ext cx="1480033" cy="1574968"/>
+            </a:xfrm>
+            <a:prstGeom prst="ellipse">
+              <a:avLst/>
+            </a:prstGeom>
+            <a:solidFill>
+              <a:srgbClr val="D93528"/>
+            </a:solidFill>
+          </p:spPr>
+          <p:style>
+            <a:lnRef idx="2">
+              <a:schemeClr val="accent1">
+                <a:shade val="15000"/>
+              </a:schemeClr>
+            </a:lnRef>
+            <a:fillRef idx="1">
+              <a:schemeClr val="accent1"/>
+            </a:fillRef>
+            <a:effectRef idx="0">
+              <a:schemeClr val="accent1"/>
+            </a:effectRef>
+            <a:fontRef idx="minor">
+              <a:schemeClr val="lt1"/>
+            </a:fontRef>
+          </p:style>
+          <p:txBody>
+            <a:bodyPr rtlCol="0" anchor="ctr"/>
+            <a:lstStyle/>
+            <a:p>
+              <a:pPr algn="ctr"/>
+              <a:r>
+                <a:rPr lang="en-US" sz="3600" dirty="0">
                   <a:solidFill>
                     <a:schemeClr val="tx1"/>
                   </a:solidFill>
                   <a:latin typeface="Tahoma" panose="020B0604030504040204" pitchFamily="34" charset="0"/>
                   <a:ea typeface="Tahoma" panose="020B0604030504040204" pitchFamily="34" charset="0"/>
                   <a:cs typeface="Tahoma" panose="020B0604030504040204" pitchFamily="34" charset="0"/>
-                </a:endParaRPr>
-              </a:p>
-            </p:txBody>
-          </p:sp>
-        </mc:Choice>
-        <mc:Fallback>
-          <p:sp>
-            <p:nvSpPr>
-              <p:cNvPr id="27" name="TextBox 26">
+                </a:rPr>
+                <a:t>O</a:t>
+              </a:r>
+            </a:p>
+          </p:txBody>
+        </p:sp>
+        <mc:AlternateContent xmlns:mc="http://schemas.openxmlformats.org/markup-compatibility/2006">
+          <mc:Choice xmlns:a14="http://schemas.microsoft.com/office/drawing/2010/main" Requires="a14">
+            <p:sp>
+              <p:nvSpPr>
+                <p:cNvPr id="9" name="TextBox 8">
+                  <a:extLst>
+                    <a:ext uri="{FF2B5EF4-FFF2-40B4-BE49-F238E27FC236}">
+                      <a16:creationId xmlns:a16="http://schemas.microsoft.com/office/drawing/2014/main" id="{B0B6BFB7-7EFB-DDC3-6926-0EB97780D9CC}"/>
+                    </a:ext>
+                  </a:extLst>
+                </p:cNvPr>
+                <p:cNvSpPr txBox="1"/>
+                <p:nvPr/>
+              </p:nvSpPr>
+              <p:spPr>
+                <a:xfrm>
+                  <a:off x="3728498" y="3670814"/>
+                  <a:ext cx="1703087" cy="584775"/>
+                </a:xfrm>
+                <a:prstGeom prst="rect">
+                  <a:avLst/>
+                </a:prstGeom>
+                <a:noFill/>
+              </p:spPr>
+              <p:txBody>
+                <a:bodyPr wrap="square" rtlCol="0">
+                  <a:spAutoFit/>
+                </a:bodyPr>
+                <a:lstStyle/>
+                <a:p>
+                  <a:pPr/>
+                  <a14:m>
+                    <m:oMathPara xmlns:m="http://schemas.openxmlformats.org/officeDocument/2006/math">
+                      <m:oMath>
+                        <m:sSub>
+                          <m:sSubPr>
+                            <m:ctrlPr>
+                              <a:rPr lang="en-US" sz="3200" b="0" i="1" smtClean="0">
+                                <a:latin typeface="Cambria Math" panose="02040503050406030204" pitchFamily="18" charset="0"/>
+                                <a:cs typeface="Times New Roman" panose="02020603050405020304" pitchFamily="18" charset="0"/>
+                              </a:rPr>
+                            </m:ctrlPr>
+                          </m:sSubPr>
+                          <m:e>
+                            <m:r>
+                              <a:rPr lang="en-US" sz="3200" b="0" i="1" smtClean="0">
+                                <a:latin typeface="Cambria Math" panose="02040503050406030204" pitchFamily="18" charset="0"/>
+                                <a:cs typeface="Times New Roman" panose="02020603050405020304" pitchFamily="18" charset="0"/>
+                              </a:rPr>
+                              <m:t>𝑟</m:t>
+                            </m:r>
+                          </m:e>
+                          <m:sub>
+                            <m:r>
+                              <a:rPr lang="en-US" sz="3200" b="0" i="1" smtClean="0">
+                                <a:latin typeface="Cambria Math" panose="02040503050406030204" pitchFamily="18" charset="0"/>
+                                <a:cs typeface="Times New Roman" panose="02020603050405020304" pitchFamily="18" charset="0"/>
+                              </a:rPr>
+                              <m:t>1</m:t>
+                            </m:r>
+                          </m:sub>
+                        </m:sSub>
+                      </m:oMath>
+                    </m:oMathPara>
+                  </a14:m>
+                  <a:endParaRPr lang="en-GB" sz="3200" dirty="0">
+                    <a:latin typeface="Times New Roman" panose="02020603050405020304" pitchFamily="18" charset="0"/>
+                    <a:cs typeface="Times New Roman" panose="02020603050405020304" pitchFamily="18" charset="0"/>
+                  </a:endParaRPr>
+                </a:p>
+              </p:txBody>
+            </p:sp>
+          </mc:Choice>
+          <mc:Fallback>
+            <p:sp>
+              <p:nvSpPr>
+                <p:cNvPr id="9" name="TextBox 8">
+                  <a:extLst>
+                    <a:ext uri="{FF2B5EF4-FFF2-40B4-BE49-F238E27FC236}">
+                      <a16:creationId xmlns:a16="http://schemas.microsoft.com/office/drawing/2014/main" id="{B0B6BFB7-7EFB-DDC3-6926-0EB97780D9CC}"/>
+                    </a:ext>
+                  </a:extLst>
+                </p:cNvPr>
+                <p:cNvSpPr txBox="1">
+                  <a:spLocks noRot="1" noChangeAspect="1" noMove="1" noResize="1" noEditPoints="1" noAdjustHandles="1" noChangeArrowheads="1" noChangeShapeType="1" noTextEdit="1"/>
+                </p:cNvSpPr>
+                <p:nvPr/>
+              </p:nvSpPr>
+              <p:spPr>
+                <a:xfrm>
+                  <a:off x="3728498" y="3670814"/>
+                  <a:ext cx="1703087" cy="584775"/>
+                </a:xfrm>
+                <a:prstGeom prst="rect">
+                  <a:avLst/>
+                </a:prstGeom>
+                <a:blipFill>
+                  <a:blip r:embed="rId2"/>
+                  <a:stretch>
+                    <a:fillRect/>
+                  </a:stretch>
+                </a:blipFill>
+              </p:spPr>
+              <p:txBody>
+                <a:bodyPr/>
+                <a:lstStyle/>
+                <a:p>
+                  <a:r>
+                    <a:rPr lang="en-GB">
+                      <a:noFill/>
+                    </a:rPr>
+                    <a:t> </a:t>
+                  </a:r>
+                </a:p>
+              </p:txBody>
+            </p:sp>
+          </mc:Fallback>
+        </mc:AlternateContent>
+        <mc:AlternateContent xmlns:mc="http://schemas.openxmlformats.org/markup-compatibility/2006">
+          <mc:Choice xmlns:a14="http://schemas.microsoft.com/office/drawing/2010/main" Requires="a14">
+            <p:sp>
+              <p:nvSpPr>
+                <p:cNvPr id="13" name="TextBox 12">
+                  <a:extLst>
+                    <a:ext uri="{FF2B5EF4-FFF2-40B4-BE49-F238E27FC236}">
+                      <a16:creationId xmlns:a16="http://schemas.microsoft.com/office/drawing/2014/main" id="{FD075C99-06C4-26D6-83AD-AD6C788886EF}"/>
+                    </a:ext>
+                  </a:extLst>
+                </p:cNvPr>
+                <p:cNvSpPr txBox="1"/>
+                <p:nvPr/>
+              </p:nvSpPr>
+              <p:spPr>
+                <a:xfrm>
+                  <a:off x="5449922" y="1500500"/>
+                  <a:ext cx="1703087" cy="584775"/>
+                </a:xfrm>
+                <a:prstGeom prst="rect">
+                  <a:avLst/>
+                </a:prstGeom>
+                <a:noFill/>
+              </p:spPr>
+              <p:txBody>
+                <a:bodyPr wrap="square" rtlCol="0">
+                  <a:spAutoFit/>
+                </a:bodyPr>
+                <a:lstStyle/>
+                <a:p>
+                  <a:pPr/>
+                  <a14:m>
+                    <m:oMathPara xmlns:m="http://schemas.openxmlformats.org/officeDocument/2006/math">
+                      <m:oMath>
+                        <m:sSub>
+                          <m:sSubPr>
+                            <m:ctrlPr>
+                              <a:rPr lang="en-US" sz="3200" b="0" i="1" smtClean="0">
+                                <a:latin typeface="Cambria Math" panose="02040503050406030204" pitchFamily="18" charset="0"/>
+                                <a:cs typeface="Times New Roman" panose="02020603050405020304" pitchFamily="18" charset="0"/>
+                              </a:rPr>
+                            </m:ctrlPr>
+                          </m:sSubPr>
+                          <m:e>
+                            <m:r>
+                              <a:rPr lang="en-US" sz="3200" b="0" i="1" smtClean="0">
+                                <a:latin typeface="Cambria Math" panose="02040503050406030204" pitchFamily="18" charset="0"/>
+                                <a:cs typeface="Times New Roman" panose="02020603050405020304" pitchFamily="18" charset="0"/>
+                              </a:rPr>
+                              <m:t>𝑟</m:t>
+                            </m:r>
+                          </m:e>
+                          <m:sub>
+                            <m:r>
+                              <a:rPr lang="en-US" sz="3200" b="0" i="1" smtClean="0">
+                                <a:latin typeface="Cambria Math" panose="02040503050406030204" pitchFamily="18" charset="0"/>
+                                <a:cs typeface="Times New Roman" panose="02020603050405020304" pitchFamily="18" charset="0"/>
+                              </a:rPr>
+                              <m:t>2</m:t>
+                            </m:r>
+                          </m:sub>
+                        </m:sSub>
+                      </m:oMath>
+                    </m:oMathPara>
+                  </a14:m>
+                  <a:endParaRPr lang="en-GB" sz="3200" dirty="0">
+                    <a:latin typeface="Times New Roman" panose="02020603050405020304" pitchFamily="18" charset="0"/>
+                    <a:cs typeface="Times New Roman" panose="02020603050405020304" pitchFamily="18" charset="0"/>
+                  </a:endParaRPr>
+                </a:p>
+              </p:txBody>
+            </p:sp>
+          </mc:Choice>
+          <mc:Fallback>
+            <p:sp>
+              <p:nvSpPr>
+                <p:cNvPr id="13" name="TextBox 12">
+                  <a:extLst>
+                    <a:ext uri="{FF2B5EF4-FFF2-40B4-BE49-F238E27FC236}">
+                      <a16:creationId xmlns:a16="http://schemas.microsoft.com/office/drawing/2014/main" id="{FD075C99-06C4-26D6-83AD-AD6C788886EF}"/>
+                    </a:ext>
+                  </a:extLst>
+                </p:cNvPr>
+                <p:cNvSpPr txBox="1">
+                  <a:spLocks noRot="1" noChangeAspect="1" noMove="1" noResize="1" noEditPoints="1" noAdjustHandles="1" noChangeArrowheads="1" noChangeShapeType="1" noTextEdit="1"/>
+                </p:cNvSpPr>
+                <p:nvPr/>
+              </p:nvSpPr>
+              <p:spPr>
+                <a:xfrm>
+                  <a:off x="5449922" y="1500500"/>
+                  <a:ext cx="1703087" cy="584775"/>
+                </a:xfrm>
+                <a:prstGeom prst="rect">
+                  <a:avLst/>
+                </a:prstGeom>
+                <a:blipFill>
+                  <a:blip r:embed="rId3"/>
+                  <a:stretch>
+                    <a:fillRect/>
+                  </a:stretch>
+                </a:blipFill>
+              </p:spPr>
+              <p:txBody>
+                <a:bodyPr/>
+                <a:lstStyle/>
+                <a:p>
+                  <a:r>
+                    <a:rPr lang="en-GB">
+                      <a:noFill/>
+                    </a:rPr>
+                    <a:t> </a:t>
+                  </a:r>
+                </a:p>
+              </p:txBody>
+            </p:sp>
+          </mc:Fallback>
+        </mc:AlternateContent>
+        <mc:AlternateContent xmlns:mc="http://schemas.openxmlformats.org/markup-compatibility/2006">
+          <mc:Choice xmlns:a14="http://schemas.microsoft.com/office/drawing/2010/main" Requires="a14">
+            <p:sp>
+              <p:nvSpPr>
+                <p:cNvPr id="15" name="TextBox 14">
+                  <a:extLst>
+                    <a:ext uri="{FF2B5EF4-FFF2-40B4-BE49-F238E27FC236}">
+                      <a16:creationId xmlns:a16="http://schemas.microsoft.com/office/drawing/2014/main" id="{D29B6249-D196-AC9D-C6B8-018AAD065877}"/>
+                    </a:ext>
+                  </a:extLst>
+                </p:cNvPr>
+                <p:cNvSpPr txBox="1"/>
+                <p:nvPr/>
+              </p:nvSpPr>
+              <p:spPr>
+                <a:xfrm>
+                  <a:off x="5186681" y="3192580"/>
+                  <a:ext cx="1703087" cy="584775"/>
+                </a:xfrm>
+                <a:prstGeom prst="rect">
+                  <a:avLst/>
+                </a:prstGeom>
+                <a:noFill/>
+              </p:spPr>
+              <p:txBody>
+                <a:bodyPr wrap="square" rtlCol="0">
+                  <a:spAutoFit/>
+                </a:bodyPr>
+                <a:lstStyle/>
+                <a:p>
+                  <a:pPr/>
+                  <a14:m>
+                    <m:oMathPara xmlns:m="http://schemas.openxmlformats.org/officeDocument/2006/math">
+                      <m:oMath>
+                        <m:r>
+                          <a:rPr lang="en-US" sz="3200" b="0" i="1" smtClean="0">
+                            <a:latin typeface="Cambria Math" panose="02040503050406030204" pitchFamily="18" charset="0"/>
+                            <a:cs typeface="Times New Roman" panose="02020603050405020304" pitchFamily="18" charset="0"/>
+                          </a:rPr>
+                          <m:t>𝜃</m:t>
+                        </m:r>
+                      </m:oMath>
+                    </m:oMathPara>
+                  </a14:m>
+                  <a:endParaRPr lang="en-GB" sz="3200" dirty="0">
+                    <a:latin typeface="Times New Roman" panose="02020603050405020304" pitchFamily="18" charset="0"/>
+                    <a:cs typeface="Times New Roman" panose="02020603050405020304" pitchFamily="18" charset="0"/>
+                  </a:endParaRPr>
+                </a:p>
+              </p:txBody>
+            </p:sp>
+          </mc:Choice>
+          <mc:Fallback>
+            <p:sp>
+              <p:nvSpPr>
+                <p:cNvPr id="15" name="TextBox 14">
+                  <a:extLst>
+                    <a:ext uri="{FF2B5EF4-FFF2-40B4-BE49-F238E27FC236}">
+                      <a16:creationId xmlns:a16="http://schemas.microsoft.com/office/drawing/2014/main" id="{D29B6249-D196-AC9D-C6B8-018AAD065877}"/>
+                    </a:ext>
+                  </a:extLst>
+                </p:cNvPr>
+                <p:cNvSpPr txBox="1">
+                  <a:spLocks noRot="1" noChangeAspect="1" noMove="1" noResize="1" noEditPoints="1" noAdjustHandles="1" noChangeArrowheads="1" noChangeShapeType="1" noTextEdit="1"/>
+                </p:cNvSpPr>
+                <p:nvPr/>
+              </p:nvSpPr>
+              <p:spPr>
+                <a:xfrm>
+                  <a:off x="5186681" y="3192580"/>
+                  <a:ext cx="1703087" cy="584775"/>
+                </a:xfrm>
+                <a:prstGeom prst="rect">
+                  <a:avLst/>
+                </a:prstGeom>
+                <a:blipFill>
+                  <a:blip r:embed="rId4"/>
+                  <a:stretch>
+                    <a:fillRect/>
+                  </a:stretch>
+                </a:blipFill>
+              </p:spPr>
+              <p:txBody>
+                <a:bodyPr/>
+                <a:lstStyle/>
+                <a:p>
+                  <a:r>
+                    <a:rPr lang="en-GB">
+                      <a:noFill/>
+                    </a:rPr>
+                    <a:t> </a:t>
+                  </a:r>
+                </a:p>
+              </p:txBody>
+            </p:sp>
+          </mc:Fallback>
+        </mc:AlternateContent>
+        <p:grpSp>
+          <p:nvGrpSpPr>
+            <p:cNvPr id="20" name="Group 19">
+              <a:extLst>
+                <a:ext uri="{FF2B5EF4-FFF2-40B4-BE49-F238E27FC236}">
+                  <a16:creationId xmlns:a16="http://schemas.microsoft.com/office/drawing/2014/main" id="{612D1359-D49E-F522-3580-95ACCFAD79ED}"/>
+                </a:ext>
+              </a:extLst>
+            </p:cNvPr>
+            <p:cNvGrpSpPr/>
+            <p:nvPr/>
+          </p:nvGrpSpPr>
+          <p:grpSpPr>
+            <a:xfrm>
+              <a:off x="6748363" y="3746943"/>
+              <a:ext cx="990759" cy="1022926"/>
+              <a:chOff x="6595459" y="3777355"/>
+              <a:chExt cx="990759" cy="1022926"/>
+            </a:xfrm>
+          </p:grpSpPr>
+          <p:cxnSp>
+            <p:nvCxnSpPr>
+              <p:cNvPr id="16" name="Straight Connector 15">
                 <a:extLst>
                   <a:ext uri="{FF2B5EF4-FFF2-40B4-BE49-F238E27FC236}">
-                    <a16:creationId xmlns:a16="http://schemas.microsoft.com/office/drawing/2014/main" id="{F65D02AF-ECCF-618C-C7C3-834ACFAC9772}"/>
+                    <a16:creationId xmlns:a16="http://schemas.microsoft.com/office/drawing/2014/main" id="{96AEE7BF-AE50-F70D-1016-7AC735D1419B}"/>
                   </a:ext>
                 </a:extLst>
               </p:cNvPr>
-              <p:cNvSpPr txBox="1">
-                <a:spLocks noRot="1" noChangeAspect="1" noMove="1" noResize="1" noEditPoints="1" noAdjustHandles="1" noChangeArrowheads="1" noChangeShapeType="1" noTextEdit="1"/>
-              </p:cNvSpPr>
+              <p:cNvCxnSpPr>
+                <a:cxnSpLocks/>
+              </p:cNvCxnSpPr>
               <p:nvPr/>
-            </p:nvSpPr>
+            </p:nvCxnSpPr>
             <p:spPr>
               <a:xfrm>
-                <a:off x="7488216" y="4612321"/>
-                <a:ext cx="687958" cy="584775"/>
+                <a:off x="6601809" y="3777355"/>
+                <a:ext cx="0" cy="1022926"/>
               </a:xfrm>
-              <a:prstGeom prst="rect">
+              <a:prstGeom prst="line">
                 <a:avLst/>
               </a:prstGeom>
-              <a:blipFill>
-                <a:blip r:embed="rId6"/>
-                <a:stretch>
-                  <a:fillRect/>
-                </a:stretch>
-              </a:blipFill>
+              <a:ln w="28575">
+                <a:headEnd type="triangle"/>
+              </a:ln>
             </p:spPr>
-            <p:txBody>
-              <a:bodyPr/>
-              <a:lstStyle/>
-              <a:p>
-                <a:r>
-                  <a:rPr lang="en-GB">
-                    <a:noFill/>
-                  </a:rPr>
-                  <a:t> </a:t>
-                </a:r>
-              </a:p>
-            </p:txBody>
-          </p:sp>
-        </mc:Fallback>
-      </mc:AlternateContent>
+            <p:style>
+              <a:lnRef idx="2">
+                <a:schemeClr val="dk1"/>
+              </a:lnRef>
+              <a:fillRef idx="0">
+                <a:schemeClr val="dk1"/>
+              </a:fillRef>
+              <a:effectRef idx="1">
+                <a:schemeClr val="dk1"/>
+              </a:effectRef>
+              <a:fontRef idx="minor">
+                <a:schemeClr val="tx1"/>
+              </a:fontRef>
+            </p:style>
+          </p:cxnSp>
+          <p:cxnSp>
+            <p:nvCxnSpPr>
+              <p:cNvPr id="18" name="Straight Connector 17">
+                <a:extLst>
+                  <a:ext uri="{FF2B5EF4-FFF2-40B4-BE49-F238E27FC236}">
+                    <a16:creationId xmlns:a16="http://schemas.microsoft.com/office/drawing/2014/main" id="{E4F6C35F-EC06-C35D-DB8C-CC0A42733084}"/>
+                  </a:ext>
+                </a:extLst>
+              </p:cNvPr>
+              <p:cNvCxnSpPr>
+                <a:cxnSpLocks/>
+              </p:cNvCxnSpPr>
+              <p:nvPr/>
+            </p:nvCxnSpPr>
+            <p:spPr>
+              <a:xfrm flipH="1">
+                <a:off x="6595459" y="4793931"/>
+                <a:ext cx="990759" cy="0"/>
+              </a:xfrm>
+              <a:prstGeom prst="line">
+                <a:avLst/>
+              </a:prstGeom>
+              <a:ln w="28575">
+                <a:headEnd type="triangle"/>
+              </a:ln>
+            </p:spPr>
+            <p:style>
+              <a:lnRef idx="2">
+                <a:schemeClr val="dk1"/>
+              </a:lnRef>
+              <a:fillRef idx="0">
+                <a:schemeClr val="dk1"/>
+              </a:fillRef>
+              <a:effectRef idx="1">
+                <a:schemeClr val="dk1"/>
+              </a:effectRef>
+              <a:fontRef idx="minor">
+                <a:schemeClr val="tx1"/>
+              </a:fontRef>
+            </p:style>
+          </p:cxnSp>
+        </p:grpSp>
+        <mc:AlternateContent xmlns:mc="http://schemas.openxmlformats.org/markup-compatibility/2006">
+          <mc:Choice xmlns:a14="http://schemas.microsoft.com/office/drawing/2010/main" Requires="a14">
+            <p:sp>
+              <p:nvSpPr>
+                <p:cNvPr id="25" name="TextBox 24">
+                  <a:extLst>
+                    <a:ext uri="{FF2B5EF4-FFF2-40B4-BE49-F238E27FC236}">
+                      <a16:creationId xmlns:a16="http://schemas.microsoft.com/office/drawing/2014/main" id="{DCAE7460-EF02-940E-C124-B9FE596D4C3B}"/>
+                    </a:ext>
+                  </a:extLst>
+                </p:cNvPr>
+                <p:cNvSpPr txBox="1"/>
+                <p:nvPr/>
+              </p:nvSpPr>
+              <p:spPr>
+                <a:xfrm>
+                  <a:off x="6748139" y="3523948"/>
+                  <a:ext cx="687958" cy="580344"/>
+                </a:xfrm>
+                <a:prstGeom prst="rect">
+                  <a:avLst/>
+                </a:prstGeom>
+                <a:noFill/>
+              </p:spPr>
+              <p:txBody>
+                <a:bodyPr wrap="square">
+                  <a:spAutoFit/>
+                </a:bodyPr>
+                <a:lstStyle/>
+                <a:p>
+                  <a:pPr algn="ctr"/>
+                  <a14:m>
+                    <m:oMathPara xmlns:m="http://schemas.openxmlformats.org/officeDocument/2006/math">
+                      <m:oMath>
+                        <m:r>
+                          <a:rPr lang="en-US" sz="2800" b="0" i="1" smtClean="0">
+                            <a:solidFill>
+                              <a:schemeClr val="tx1"/>
+                            </a:solidFill>
+                            <a:latin typeface="Cambria Math" panose="02040503050406030204" pitchFamily="18" charset="0"/>
+                            <a:ea typeface="Tahoma" panose="020B0604030504040204" pitchFamily="34" charset="0"/>
+                            <a:cs typeface="Tahoma" panose="020B0604030504040204" pitchFamily="34" charset="0"/>
+                          </a:rPr>
+                          <m:t>𝑧</m:t>
+                        </m:r>
+                      </m:oMath>
+                    </m:oMathPara>
+                  </a14:m>
+                  <a:endParaRPr lang="en-US" sz="3200" dirty="0">
+                    <a:solidFill>
+                      <a:schemeClr val="tx1"/>
+                    </a:solidFill>
+                    <a:latin typeface="Tahoma" panose="020B0604030504040204" pitchFamily="34" charset="0"/>
+                    <a:ea typeface="Tahoma" panose="020B0604030504040204" pitchFamily="34" charset="0"/>
+                    <a:cs typeface="Tahoma" panose="020B0604030504040204" pitchFamily="34" charset="0"/>
+                  </a:endParaRPr>
+                </a:p>
+              </p:txBody>
+            </p:sp>
+          </mc:Choice>
+          <mc:Fallback>
+            <p:sp>
+              <p:nvSpPr>
+                <p:cNvPr id="25" name="TextBox 24">
+                  <a:extLst>
+                    <a:ext uri="{FF2B5EF4-FFF2-40B4-BE49-F238E27FC236}">
+                      <a16:creationId xmlns:a16="http://schemas.microsoft.com/office/drawing/2014/main" id="{DCAE7460-EF02-940E-C124-B9FE596D4C3B}"/>
+                    </a:ext>
+                  </a:extLst>
+                </p:cNvPr>
+                <p:cNvSpPr txBox="1">
+                  <a:spLocks noRot="1" noChangeAspect="1" noMove="1" noResize="1" noEditPoints="1" noAdjustHandles="1" noChangeArrowheads="1" noChangeShapeType="1" noTextEdit="1"/>
+                </p:cNvSpPr>
+                <p:nvPr/>
+              </p:nvSpPr>
+              <p:spPr>
+                <a:xfrm>
+                  <a:off x="6748139" y="3523948"/>
+                  <a:ext cx="687958" cy="580344"/>
+                </a:xfrm>
+                <a:prstGeom prst="rect">
+                  <a:avLst/>
+                </a:prstGeom>
+                <a:blipFill>
+                  <a:blip r:embed="rId5"/>
+                  <a:stretch>
+                    <a:fillRect/>
+                  </a:stretch>
+                </a:blipFill>
+              </p:spPr>
+              <p:txBody>
+                <a:bodyPr/>
+                <a:lstStyle/>
+                <a:p>
+                  <a:r>
+                    <a:rPr lang="en-GB">
+                      <a:noFill/>
+                    </a:rPr>
+                    <a:t> </a:t>
+                  </a:r>
+                </a:p>
+              </p:txBody>
+            </p:sp>
+          </mc:Fallback>
+        </mc:AlternateContent>
+        <mc:AlternateContent xmlns:mc="http://schemas.openxmlformats.org/markup-compatibility/2006">
+          <mc:Choice xmlns:a14="http://schemas.microsoft.com/office/drawing/2010/main" Requires="a14">
+            <p:sp>
+              <p:nvSpPr>
+                <p:cNvPr id="27" name="TextBox 26">
+                  <a:extLst>
+                    <a:ext uri="{FF2B5EF4-FFF2-40B4-BE49-F238E27FC236}">
+                      <a16:creationId xmlns:a16="http://schemas.microsoft.com/office/drawing/2014/main" id="{F65D02AF-ECCF-618C-C7C3-834ACFAC9772}"/>
+                    </a:ext>
+                  </a:extLst>
+                </p:cNvPr>
+                <p:cNvSpPr txBox="1"/>
+                <p:nvPr/>
+              </p:nvSpPr>
+              <p:spPr>
+                <a:xfrm>
+                  <a:off x="7488216" y="4612321"/>
+                  <a:ext cx="687958" cy="584775"/>
+                </a:xfrm>
+                <a:prstGeom prst="rect">
+                  <a:avLst/>
+                </a:prstGeom>
+                <a:noFill/>
+              </p:spPr>
+              <p:txBody>
+                <a:bodyPr wrap="square">
+                  <a:spAutoFit/>
+                </a:bodyPr>
+                <a:lstStyle/>
+                <a:p>
+                  <a:pPr algn="ctr"/>
+                  <a14:m>
+                    <m:oMathPara xmlns:m="http://schemas.openxmlformats.org/officeDocument/2006/math">
+                      <m:oMath>
+                        <m:r>
+                          <a:rPr lang="en-US" sz="3200" b="0" i="1" smtClean="0">
+                            <a:solidFill>
+                              <a:schemeClr val="tx1"/>
+                            </a:solidFill>
+                            <a:latin typeface="Cambria Math" panose="02040503050406030204" pitchFamily="18" charset="0"/>
+                            <a:ea typeface="Tahoma" panose="020B0604030504040204" pitchFamily="34" charset="0"/>
+                            <a:cs typeface="Tahoma" panose="020B0604030504040204" pitchFamily="34" charset="0"/>
+                          </a:rPr>
+                          <m:t>𝑥</m:t>
+                        </m:r>
+                      </m:oMath>
+                    </m:oMathPara>
+                  </a14:m>
+                  <a:endParaRPr lang="en-US" sz="3200" dirty="0">
+                    <a:solidFill>
+                      <a:schemeClr val="tx1"/>
+                    </a:solidFill>
+                    <a:latin typeface="Tahoma" panose="020B0604030504040204" pitchFamily="34" charset="0"/>
+                    <a:ea typeface="Tahoma" panose="020B0604030504040204" pitchFamily="34" charset="0"/>
+                    <a:cs typeface="Tahoma" panose="020B0604030504040204" pitchFamily="34" charset="0"/>
+                  </a:endParaRPr>
+                </a:p>
+              </p:txBody>
+            </p:sp>
+          </mc:Choice>
+          <mc:Fallback>
+            <p:sp>
+              <p:nvSpPr>
+                <p:cNvPr id="27" name="TextBox 26">
+                  <a:extLst>
+                    <a:ext uri="{FF2B5EF4-FFF2-40B4-BE49-F238E27FC236}">
+                      <a16:creationId xmlns:a16="http://schemas.microsoft.com/office/drawing/2014/main" id="{F65D02AF-ECCF-618C-C7C3-834ACFAC9772}"/>
+                    </a:ext>
+                  </a:extLst>
+                </p:cNvPr>
+                <p:cNvSpPr txBox="1">
+                  <a:spLocks noRot="1" noChangeAspect="1" noMove="1" noResize="1" noEditPoints="1" noAdjustHandles="1" noChangeArrowheads="1" noChangeShapeType="1" noTextEdit="1"/>
+                </p:cNvSpPr>
+                <p:nvPr/>
+              </p:nvSpPr>
+              <p:spPr>
+                <a:xfrm>
+                  <a:off x="7488216" y="4612321"/>
+                  <a:ext cx="687958" cy="584775"/>
+                </a:xfrm>
+                <a:prstGeom prst="rect">
+                  <a:avLst/>
+                </a:prstGeom>
+                <a:blipFill>
+                  <a:blip r:embed="rId6"/>
+                  <a:stretch>
+                    <a:fillRect/>
+                  </a:stretch>
+                </a:blipFill>
+              </p:spPr>
+              <p:txBody>
+                <a:bodyPr/>
+                <a:lstStyle/>
+                <a:p>
+                  <a:r>
+                    <a:rPr lang="en-GB">
+                      <a:noFill/>
+                    </a:rPr>
+                    <a:t> </a:t>
+                  </a:r>
+                </a:p>
+              </p:txBody>
+            </p:sp>
+          </mc:Fallback>
+        </mc:AlternateContent>
+      </p:grpSp>
     </p:spTree>
     <p:extLst>
       <p:ext uri="{BB962C8B-B14F-4D97-AF65-F5344CB8AC3E}">

</xml_diff>